<commit_message>
docs: deck and demo video point at the Google Cloud Run deployment
Video re-recorded against Cloud Run with a register-photo scene, updated
Sarvam narration and an on-screen link; deck shows the Cloud Run link,
photo reading, KMS-signed orders and the Google Cloud stack.

Co-Authored-By: Claude Opus 5.5 <noreply@anthropic.com>
</commit_message>
<xml_diff>
--- a/docs/pitch/AushadhiNet-pitch.pptx
+++ b/docs/pitch/AushadhiNet-pitch.pptx
@@ -3288,7 +3288,7 @@
               </a:defRPr>
             </a:pPr>
             <a:r>
-              <a:t>Live: aushadhinet-frontend.onrender.com</a:t>
+              <a:t>Live on Google Cloud Run: aushadhinet-frontend-449585498230.asia-south1.run.app</a:t>
             </a:r>
           </a:p>
           <a:p>
@@ -3464,7 +3464,7 @@
               </a:defRPr>
             </a:pPr>
             <a:r>
-              <a:t>Built on Google</a:t>
+              <a:t>Running on Google Cloud</a:t>
             </a:r>
           </a:p>
         </p:txBody>
@@ -3502,7 +3502,7 @@
               </a:defRPr>
             </a:pPr>
             <a:r>
-              <a:t>Google OR-Tools · Gemini (provider seam) · Firestore / Cloud Run (scripted)</a:t>
+              <a:t>Cloud Run · Firestore · BigQuery · Pub/Sub · Cloud KMS · Secret Manager (Terraform)</a:t>
             </a:r>
           </a:p>
           <a:p>
@@ -3517,7 +3517,7 @@
               </a:defRPr>
             </a:pPr>
             <a:r>
-              <a:t>LightGBM · FastAPI · Next.js 15 · Leaflet + OpenStreetMap</a:t>
+              <a:t>Gemini (register photos) · Vertex AI embeddings · Google OR-Tools</a:t>
             </a:r>
           </a:p>
           <a:p>
@@ -3532,7 +3532,7 @@
               </a:defRPr>
             </a:pPr>
             <a:r>
-              <a:t>348 backend tests · 13 Playwright E2E, passing on the live deployment</a:t>
+              <a:t>LightGBM · FastAPI · Next.js 15 · 348 automated tests</a:t>
             </a:r>
           </a:p>
         </p:txBody>
@@ -3698,7 +3698,7 @@
               </a:defRPr>
             </a:pPr>
             <a:r>
-              <a:t>Live: aushadhinet-frontend.onrender.com</a:t>
+              <a:t>Live on Google Cloud Run: aushadhinet-frontend-449585498230.asia-south1.run.app</a:t>
             </a:r>
           </a:p>
         </p:txBody>
@@ -4749,7 +4749,7 @@
               </a:defRPr>
             </a:pPr>
             <a:r>
-              <a:t>Plain text, any script, native digits</a:t>
+              <a:t>Text in any script, or a photo of the register</a:t>
             </a:r>
           </a:p>
           <a:p>
@@ -4764,7 +4764,7 @@
               </a:defRPr>
             </a:pPr>
             <a:r>
-              <a:t>Low-confidence reads need a Confirm tap</a:t>
+              <a:t>Gemini reads every line of a photo</a:t>
             </a:r>
           </a:p>
           <a:p>
@@ -4779,7 +4779,7 @@
               </a:defRPr>
             </a:pPr>
             <a:r>
-              <a:t>Nothing unconfirmed reaches the forecast</a:t>
+              <a:t>Nothing is saved until the nurse confirms</a:t>
             </a:r>
           </a:p>
         </p:txBody>
@@ -4793,7 +4793,7 @@
           <p:nvPr/>
         </p:nvPicPr>
         <p:blipFill>
-          <a:blip r:embed="rId2"/>
+          <a:blip r:embed="rId3"/>
           <a:stretch>
             <a:fillRect/>
           </a:stretch>
@@ -5237,7 +5237,7 @@
               </a:defRPr>
             </a:pPr>
             <a:r>
-              <a:t>Orders are signed; both ends notified</a:t>
+              <a:t>Orders signed with Cloud KMS; both ends notified</a:t>
             </a:r>
           </a:p>
         </p:txBody>
@@ -6707,7 +6707,7 @@
               </a:defRPr>
             </a:pPr>
             <a:r>
-              <a:t>362</a:t>
+              <a:t>348</a:t>
             </a:r>
           </a:p>
         </p:txBody>
@@ -6742,7 +6742,7 @@
               </a:defRPr>
             </a:pPr>
             <a:r>
-              <a:t>automated tests passing (349 backend + 13 E2E)</a:t>
+              <a:t>automated tests (334 backend + 14 E2E, passing on Cloud Run)</a:t>
             </a:r>
           </a:p>
         </p:txBody>

</xml_diff>

<commit_message>
fix: agent note compares numbers without thousands separators; log why a note is dropped
On Cloud Run no note ever appeared; '31,547' read as two new numbers is the
likely cause. Drop and skip reasons now go to the logs.
Also: deck gains the photo-reading and rollout slides; tasklist updated.

Co-Authored-By: Claude Opus 5.5 <noreply@anthropic.com>
</commit_message>
<xml_diff>
--- a/docs/pitch/AushadhiNet-pitch.pptx
+++ b/docs/pitch/AushadhiNet-pitch.pptx
@@ -14,6 +14,8 @@
     <p:sldId id="262" r:id="rId13"/>
     <p:sldId id="263" r:id="rId14"/>
     <p:sldId id="267" r:id="rId15"/>
+    <p:sldId id="269" r:id="rId18"/>
+    <p:sldId id="270" r:id="rId19"/>
     <p:sldId id="265" r:id="rId16"/>
     <p:sldId id="268" r:id="rId17"/>
   </p:sldIdLst>
@@ -3426,7 +3428,7 @@
               </a:defRPr>
             </a:pPr>
             <a:r>
-              <a:t>Tech</a:t>
+              <a:t>Google AI in the loop</a:t>
             </a:r>
           </a:p>
         </p:txBody>
@@ -3464,7 +3466,7 @@
               </a:defRPr>
             </a:pPr>
             <a:r>
-              <a:t>Running on Google Cloud</a:t>
+              <a:t>Gemini reads register photos</a:t>
             </a:r>
           </a:p>
         </p:txBody>
@@ -3478,7 +3480,7 @@
         <p:spPr>
           <a:xfrm>
             <a:off x="640080" y="1828800"/>
-            <a:ext cx="10972800" cy="2743200"/>
+            <a:ext cx="3566160" cy="822960"/>
           </a:xfrm>
           <a:prstGeom prst="rect">
             <a:avLst/>
@@ -3495,44 +3497,272 @@
               <a:spcAft>
                 <a:spcPts val="1000"/>
               </a:spcAft>
-              <a:defRPr sz="2000" b="0">
-                <a:solidFill>
-                  <a:srgbClr val="18181B"/>
-                </a:solidFill>
-              </a:defRPr>
-            </a:pPr>
-            <a:r>
-              <a:t>Cloud Run · Firestore · BigQuery · Pub/Sub · Cloud KMS · Secret Manager (Terraform)</a:t>
-            </a:r>
-          </a:p>
+              <a:defRPr sz="4400" b="1">
+                <a:solidFill>
+                  <a:srgbClr val="0F766E"/>
+                </a:solidFill>
+              </a:defRPr>
+            </a:pPr>
+            <a:r>
+              <a:t>100%</a:t>
+            </a:r>
+          </a:p>
+        </p:txBody>
+      </p:sp>
+      <p:sp>
+        <p:nvSpPr>
+          <p:cNvPr id="6" name="TextBox 5"/>
+          <p:cNvSpPr txBox="1"/>
+          <p:nvPr/>
+        </p:nvSpPr>
+        <p:spPr>
+          <a:xfrm>
+            <a:off x="640080" y="2743200"/>
+            <a:ext cx="3566160" cy="731520"/>
+          </a:xfrm>
+          <a:prstGeom prst="rect">
+            <a:avLst/>
+          </a:prstGeom>
+          <a:noFill/>
+        </p:spPr>
+        <p:txBody>
+          <a:bodyPr wrap="square">
+            <a:spAutoFit/>
+          </a:bodyPr>
+          <a:lstStyle/>
           <a:p>
             <a:pPr>
               <a:spcAft>
                 <a:spcPts val="1000"/>
               </a:spcAft>
-              <a:defRPr sz="2000" b="0">
-                <a:solidFill>
-                  <a:srgbClr val="18181B"/>
-                </a:solidFill>
-              </a:defRPr>
-            </a:pPr>
-            <a:r>
-              <a:t>Gemini (register photos) · Vertex AI embeddings · Google OR-Tools</a:t>
-            </a:r>
-          </a:p>
+              <a:defRPr sz="1500" b="0">
+                <a:solidFill>
+                  <a:srgbClr val="52525B"/>
+                </a:solidFill>
+              </a:defRPr>
+            </a:pPr>
+            <a:r>
+              <a:t>quantity read correctly</a:t>
+            </a:r>
+          </a:p>
+        </p:txBody>
+      </p:sp>
+      <p:sp>
+        <p:nvSpPr>
+          <p:cNvPr id="7" name="TextBox 6"/>
+          <p:cNvSpPr txBox="1"/>
+          <p:nvPr/>
+        </p:nvSpPr>
+        <p:spPr>
+          <a:xfrm>
+            <a:off x="4389120" y="1828800"/>
+            <a:ext cx="3566160" cy="822960"/>
+          </a:xfrm>
+          <a:prstGeom prst="rect">
+            <a:avLst/>
+          </a:prstGeom>
+          <a:noFill/>
+        </p:spPr>
+        <p:txBody>
+          <a:bodyPr wrap="square">
+            <a:spAutoFit/>
+          </a:bodyPr>
+          <a:lstStyle/>
           <a:p>
             <a:pPr>
               <a:spcAft>
                 <a:spcPts val="1000"/>
               </a:spcAft>
-              <a:defRPr sz="2000" b="0">
+              <a:defRPr sz="4400" b="1">
+                <a:solidFill>
+                  <a:srgbClr val="0F766E"/>
+                </a:solidFill>
+              </a:defRPr>
+            </a:pPr>
+            <a:r>
+              <a:t>98.1%</a:t>
+            </a:r>
+          </a:p>
+        </p:txBody>
+      </p:sp>
+      <p:sp>
+        <p:nvSpPr>
+          <p:cNvPr id="8" name="TextBox 7"/>
+          <p:cNvSpPr txBox="1"/>
+          <p:nvPr/>
+        </p:nvSpPr>
+        <p:spPr>
+          <a:xfrm>
+            <a:off x="4389120" y="2743200"/>
+            <a:ext cx="3566160" cy="731520"/>
+          </a:xfrm>
+          <a:prstGeom prst="rect">
+            <a:avLst/>
+          </a:prstGeom>
+          <a:noFill/>
+        </p:spPr>
+        <p:txBody>
+          <a:bodyPr wrap="square">
+            <a:spAutoFit/>
+          </a:bodyPr>
+          <a:lstStyle/>
+          <a:p>
+            <a:pPr>
+              <a:spcAft>
+                <a:spcPts val="1000"/>
+              </a:spcAft>
+              <a:defRPr sz="1500" b="0">
+                <a:solidFill>
+                  <a:srgbClr val="52525B"/>
+                </a:solidFill>
+              </a:defRPr>
+            </a:pPr>
+            <a:r>
+              <a:t>medicine matched</a:t>
+            </a:r>
+          </a:p>
+        </p:txBody>
+      </p:sp>
+      <p:sp>
+        <p:nvSpPr>
+          <p:cNvPr id="9" name="TextBox 8"/>
+          <p:cNvSpPr txBox="1"/>
+          <p:nvPr/>
+        </p:nvSpPr>
+        <p:spPr>
+          <a:xfrm>
+            <a:off x="8138159" y="1828800"/>
+            <a:ext cx="3566160" cy="822960"/>
+          </a:xfrm>
+          <a:prstGeom prst="rect">
+            <a:avLst/>
+          </a:prstGeom>
+          <a:noFill/>
+        </p:spPr>
+        <p:txBody>
+          <a:bodyPr wrap="square">
+            <a:spAutoFit/>
+          </a:bodyPr>
+          <a:lstStyle/>
+          <a:p>
+            <a:pPr>
+              <a:spcAft>
+                <a:spcPts val="1000"/>
+              </a:spcAft>
+              <a:defRPr sz="4400" b="1">
+                <a:solidFill>
+                  <a:srgbClr val="0F766E"/>
+                </a:solidFill>
+              </a:defRPr>
+            </a:pPr>
+            <a:r>
+              <a:t>4</a:t>
+            </a:r>
+          </a:p>
+        </p:txBody>
+      </p:sp>
+      <p:sp>
+        <p:nvSpPr>
+          <p:cNvPr id="10" name="TextBox 9"/>
+          <p:cNvSpPr txBox="1"/>
+          <p:nvPr/>
+        </p:nvSpPr>
+        <p:spPr>
+          <a:xfrm>
+            <a:off x="8138159" y="2743200"/>
+            <a:ext cx="3566160" cy="731520"/>
+          </a:xfrm>
+          <a:prstGeom prst="rect">
+            <a:avLst/>
+          </a:prstGeom>
+          <a:noFill/>
+        </p:spPr>
+        <p:txBody>
+          <a:bodyPr wrap="square">
+            <a:spAutoFit/>
+          </a:bodyPr>
+          <a:lstStyle/>
+          <a:p>
+            <a:pPr>
+              <a:spcAft>
+                <a:spcPts val="1000"/>
+              </a:spcAft>
+              <a:defRPr sz="1500" b="0">
+                <a:solidFill>
+                  <a:srgbClr val="52525B"/>
+                </a:solidFill>
+              </a:defRPr>
+            </a:pPr>
+            <a:r>
+              <a:t>scripts: English, Devanagari, Tamil, Bengali</a:t>
+            </a:r>
+          </a:p>
+        </p:txBody>
+      </p:sp>
+      <p:sp>
+        <p:nvSpPr>
+          <p:cNvPr id="11" name="TextBox 10"/>
+          <p:cNvSpPr txBox="1"/>
+          <p:nvPr/>
+        </p:nvSpPr>
+        <p:spPr>
+          <a:xfrm>
+            <a:off x="640080" y="3840480"/>
+            <a:ext cx="10972800" cy="2286000"/>
+          </a:xfrm>
+          <a:prstGeom prst="rect">
+            <a:avLst/>
+          </a:prstGeom>
+          <a:noFill/>
+        </p:spPr>
+        <p:txBody>
+          <a:bodyPr wrap="square">
+            <a:spAutoFit/>
+          </a:bodyPr>
+          <a:lstStyle/>
+          <a:p>
+            <a:pPr>
+              <a:spcAft>
+                <a:spcPts val="1000"/>
+              </a:spcAft>
+              <a:defRPr sz="1600" b="0">
                 <a:solidFill>
                   <a:srgbClr val="18181B"/>
                 </a:solidFill>
               </a:defRPr>
             </a:pPr>
             <a:r>
-              <a:t>LightGBM · FastAPI · Next.js 15 · 348 automated tests</a:t>
+              <a:t>Measured on 206 rendered register lines (synthetic text, not real handwriting photos).</a:t>
+            </a:r>
+          </a:p>
+          <a:p>
+            <a:pPr>
+              <a:spcAft>
+                <a:spcPts val="1000"/>
+              </a:spcAft>
+              <a:defRPr sz="1600" b="0">
+                <a:solidFill>
+                  <a:srgbClr val="18181B"/>
+                </a:solidFill>
+              </a:defRPr>
+            </a:pPr>
+            <a:r>
+              <a:t>Every photo read is confirmed by the nurse before it is saved: a model can be confidently wrong.</a:t>
+            </a:r>
+          </a:p>
+          <a:p>
+            <a:pPr>
+              <a:spcAft>
+                <a:spcPts val="1000"/>
+              </a:spcAft>
+              <a:defRPr sz="1600" b="0">
+                <a:solidFill>
+                  <a:srgbClr val="18181B"/>
+                </a:solidFill>
+              </a:defRPr>
+            </a:pPr>
+            <a:r>
+              <a:t>Next: measure on real register photos in the pilot.</a:t>
             </a:r>
           </a:p>
         </p:txBody>
@@ -3546,6 +3776,629 @@
 </file>
 
 <file path=ppt/slides/slide11.xml><?xml version="1.0" encoding="utf-8"?>
+<p:sld xmlns:a="http://schemas.openxmlformats.org/drawingml/2006/main" xmlns:p="http://schemas.openxmlformats.org/presentationml/2006/main" xmlns:r="http://schemas.openxmlformats.org/officeDocument/2006/relationships">
+  <p:cSld>
+    <p:spTree>
+      <p:nvGrpSpPr>
+        <p:cNvPr id="1" name=""/>
+        <p:cNvGrpSpPr/>
+        <p:nvPr/>
+      </p:nvGrpSpPr>
+      <p:grpSpPr/>
+      <p:sp>
+        <p:nvSpPr>
+          <p:cNvPr id="2" name="Rectangle 1"/>
+          <p:cNvSpPr/>
+          <p:nvPr/>
+        </p:nvSpPr>
+        <p:spPr>
+          <a:xfrm>
+            <a:off x="0" y="0"/>
+            <a:ext cx="164592" cy="6858000"/>
+          </a:xfrm>
+          <a:prstGeom prst="rect">
+            <a:avLst/>
+          </a:prstGeom>
+          <a:solidFill>
+            <a:srgbClr val="0F766E"/>
+          </a:solidFill>
+          <a:ln>
+            <a:noFill/>
+          </a:ln>
+        </p:spPr>
+        <p:style>
+          <a:lnRef idx="1">
+            <a:schemeClr val="accent1"/>
+          </a:lnRef>
+          <a:fillRef idx="3">
+            <a:schemeClr val="accent1"/>
+          </a:fillRef>
+          <a:effectRef idx="2">
+            <a:schemeClr val="accent1"/>
+          </a:effectRef>
+          <a:fontRef idx="minor">
+            <a:schemeClr val="lt1"/>
+          </a:fontRef>
+        </p:style>
+        <p:txBody>
+          <a:bodyPr rtlCol="0" anchor="ctr"/>
+          <a:lstStyle/>
+          <a:p>
+            <a:pPr algn="ctr"/>
+          </a:p>
+        </p:txBody>
+      </p:sp>
+      <p:sp>
+        <p:nvSpPr>
+          <p:cNvPr id="3" name="TextBox 2"/>
+          <p:cNvSpPr txBox="1"/>
+          <p:nvPr/>
+        </p:nvSpPr>
+        <p:spPr>
+          <a:xfrm>
+            <a:off x="640080" y="411480"/>
+            <a:ext cx="10972800" cy="365760"/>
+          </a:xfrm>
+          <a:prstGeom prst="rect">
+            <a:avLst/>
+          </a:prstGeom>
+          <a:noFill/>
+        </p:spPr>
+        <p:txBody>
+          <a:bodyPr wrap="square">
+            <a:spAutoFit/>
+          </a:bodyPr>
+          <a:lstStyle/>
+          <a:p>
+            <a:pPr>
+              <a:spcAft>
+                <a:spcPts val="1000"/>
+              </a:spcAft>
+              <a:defRPr sz="1400" b="1">
+                <a:solidFill>
+                  <a:srgbClr val="0F766E"/>
+                </a:solidFill>
+              </a:defRPr>
+            </a:pPr>
+            <a:r>
+              <a:t>Rollout</a:t>
+            </a:r>
+          </a:p>
+        </p:txBody>
+      </p:sp>
+      <p:sp>
+        <p:nvSpPr>
+          <p:cNvPr id="4" name="TextBox 3"/>
+          <p:cNvSpPr txBox="1"/>
+          <p:nvPr/>
+        </p:nvSpPr>
+        <p:spPr>
+          <a:xfrm>
+            <a:off x="640080" y="731520"/>
+            <a:ext cx="10972800" cy="914400"/>
+          </a:xfrm>
+          <a:prstGeom prst="rect">
+            <a:avLst/>
+          </a:prstGeom>
+          <a:noFill/>
+        </p:spPr>
+        <p:txBody>
+          <a:bodyPr wrap="square">
+            <a:spAutoFit/>
+          </a:bodyPr>
+          <a:lstStyle/>
+          <a:p>
+            <a:pPr>
+              <a:spcAft>
+                <a:spcPts val="1000"/>
+              </a:spcAft>
+              <a:defRPr sz="3400" b="1">
+                <a:solidFill>
+                  <a:srgbClr val="18181B"/>
+                </a:solidFill>
+              </a:defRPr>
+            </a:pPr>
+            <a:r>
+              <a:t>From one block to a state, on Google Cloud</a:t>
+            </a:r>
+          </a:p>
+        </p:txBody>
+      </p:sp>
+      <p:sp>
+        <p:nvSpPr>
+          <p:cNvPr id="5" name="TextBox 4"/>
+          <p:cNvSpPr txBox="1"/>
+          <p:nvPr/>
+        </p:nvSpPr>
+        <p:spPr>
+          <a:xfrm>
+            <a:off x="640080" y="1828800"/>
+            <a:ext cx="3566160" cy="548640"/>
+          </a:xfrm>
+          <a:prstGeom prst="rect">
+            <a:avLst/>
+          </a:prstGeom>
+          <a:noFill/>
+        </p:spPr>
+        <p:txBody>
+          <a:bodyPr wrap="square">
+            <a:spAutoFit/>
+          </a:bodyPr>
+          <a:lstStyle/>
+          <a:p>
+            <a:pPr>
+              <a:spcAft>
+                <a:spcPts val="1000"/>
+              </a:spcAft>
+              <a:defRPr sz="2200" b="1">
+                <a:solidFill>
+                  <a:srgbClr val="0F766E"/>
+                </a:solidFill>
+              </a:defRPr>
+            </a:pPr>
+            <a:r>
+              <a:t>Pilot</a:t>
+            </a:r>
+          </a:p>
+        </p:txBody>
+      </p:sp>
+      <p:sp>
+        <p:nvSpPr>
+          <p:cNvPr id="6" name="TextBox 5"/>
+          <p:cNvSpPr txBox="1"/>
+          <p:nvPr/>
+        </p:nvSpPr>
+        <p:spPr>
+          <a:xfrm>
+            <a:off x="640080" y="2468880"/>
+            <a:ext cx="3474720" cy="2011680"/>
+          </a:xfrm>
+          <a:prstGeom prst="rect">
+            <a:avLst/>
+          </a:prstGeom>
+          <a:noFill/>
+        </p:spPr>
+        <p:txBody>
+          <a:bodyPr wrap="square">
+            <a:spAutoFit/>
+          </a:bodyPr>
+          <a:lstStyle/>
+          <a:p>
+            <a:pPr>
+              <a:spcAft>
+                <a:spcPts val="1000"/>
+              </a:spcAft>
+              <a:defRPr sz="1500" b="0">
+                <a:solidFill>
+                  <a:srgbClr val="18181B"/>
+                </a:solidFill>
+              </a:defRPr>
+            </a:pPr>
+            <a:r>
+              <a:t>1 Nashik block: nurses' WhatsApp numbers, real register photos, 1 officer approving transfers</a:t>
+            </a:r>
+          </a:p>
+        </p:txBody>
+      </p:sp>
+      <p:sp>
+        <p:nvSpPr>
+          <p:cNvPr id="7" name="TextBox 6"/>
+          <p:cNvSpPr txBox="1"/>
+          <p:nvPr/>
+        </p:nvSpPr>
+        <p:spPr>
+          <a:xfrm>
+            <a:off x="4389120" y="1828800"/>
+            <a:ext cx="3566160" cy="548640"/>
+          </a:xfrm>
+          <a:prstGeom prst="rect">
+            <a:avLst/>
+          </a:prstGeom>
+          <a:noFill/>
+        </p:spPr>
+        <p:txBody>
+          <a:bodyPr wrap="square">
+            <a:spAutoFit/>
+          </a:bodyPr>
+          <a:lstStyle/>
+          <a:p>
+            <a:pPr>
+              <a:spcAft>
+                <a:spcPts val="1000"/>
+              </a:spcAft>
+              <a:defRPr sz="2200" b="1">
+                <a:solidFill>
+                  <a:srgbClr val="0F766E"/>
+                </a:solidFill>
+              </a:defRPr>
+            </a:pPr>
+            <a:r>
+              <a:t>District</a:t>
+            </a:r>
+          </a:p>
+        </p:txBody>
+      </p:sp>
+      <p:sp>
+        <p:nvSpPr>
+          <p:cNvPr id="8" name="TextBox 7"/>
+          <p:cNvSpPr txBox="1"/>
+          <p:nvPr/>
+        </p:nvSpPr>
+        <p:spPr>
+          <a:xfrm>
+            <a:off x="4389120" y="2468880"/>
+            <a:ext cx="3474720" cy="2011680"/>
+          </a:xfrm>
+          <a:prstGeom prst="rect">
+            <a:avLst/>
+          </a:prstGeom>
+          <a:noFill/>
+        </p:spPr>
+        <p:txBody>
+          <a:bodyPr wrap="square">
+            <a:spAutoFit/>
+          </a:bodyPr>
+          <a:lstStyle/>
+          <a:p>
+            <a:pPr>
+              <a:spcAft>
+                <a:spcPts val="1000"/>
+              </a:spcAft>
+              <a:defRPr sz="1500" b="0">
+                <a:solidFill>
+                  <a:srgbClr val="18181B"/>
+                </a:solidFill>
+              </a:defRPr>
+            </a:pPr>
+            <a:r>
+              <a:t>760 facilities: forecasts and transfer drafts weekly; measure stock-out weeks against last year</a:t>
+            </a:r>
+          </a:p>
+        </p:txBody>
+      </p:sp>
+      <p:sp>
+        <p:nvSpPr>
+          <p:cNvPr id="9" name="TextBox 8"/>
+          <p:cNvSpPr txBox="1"/>
+          <p:nvPr/>
+        </p:nvSpPr>
+        <p:spPr>
+          <a:xfrm>
+            <a:off x="8138159" y="1828800"/>
+            <a:ext cx="3566160" cy="548640"/>
+          </a:xfrm>
+          <a:prstGeom prst="rect">
+            <a:avLst/>
+          </a:prstGeom>
+          <a:noFill/>
+        </p:spPr>
+        <p:txBody>
+          <a:bodyPr wrap="square">
+            <a:spAutoFit/>
+          </a:bodyPr>
+          <a:lstStyle/>
+          <a:p>
+            <a:pPr>
+              <a:spcAft>
+                <a:spcPts val="1000"/>
+              </a:spcAft>
+              <a:defRPr sz="2200" b="1">
+                <a:solidFill>
+                  <a:srgbClr val="0F766E"/>
+                </a:solidFill>
+              </a:defRPr>
+            </a:pPr>
+            <a:r>
+              <a:t>State</a:t>
+            </a:r>
+          </a:p>
+        </p:txBody>
+      </p:sp>
+      <p:sp>
+        <p:nvSpPr>
+          <p:cNvPr id="10" name="TextBox 9"/>
+          <p:cNvSpPr txBox="1"/>
+          <p:nvPr/>
+        </p:nvSpPr>
+        <p:spPr>
+          <a:xfrm>
+            <a:off x="8138159" y="2468880"/>
+            <a:ext cx="3474720" cy="2011680"/>
+          </a:xfrm>
+          <a:prstGeom prst="rect">
+            <a:avLst/>
+          </a:prstGeom>
+          <a:noFill/>
+        </p:spPr>
+        <p:txBody>
+          <a:bodyPr wrap="square">
+            <a:spAutoFit/>
+          </a:bodyPr>
+          <a:lstStyle/>
+          <a:p>
+            <a:pPr>
+              <a:spcAft>
+                <a:spcPts val="1000"/>
+              </a:spcAft>
+              <a:defRPr sz="1500" b="0">
+                <a:solidFill>
+                  <a:srgbClr val="18181B"/>
+                </a:solidFill>
+              </a:defRPr>
+            </a:pPr>
+            <a:r>
+              <a:t>One GCP project per state (Terraform), so raw facility data stays in the state; federated model updates only</a:t>
+            </a:r>
+          </a:p>
+        </p:txBody>
+      </p:sp>
+      <p:sp>
+        <p:nvSpPr>
+          <p:cNvPr id="11" name="TextBox 10"/>
+          <p:cNvSpPr txBox="1"/>
+          <p:nvPr/>
+        </p:nvSpPr>
+        <p:spPr>
+          <a:xfrm>
+            <a:off x="640080" y="4754880"/>
+            <a:ext cx="10972800" cy="1463040"/>
+          </a:xfrm>
+          <a:prstGeom prst="rect">
+            <a:avLst/>
+          </a:prstGeom>
+          <a:noFill/>
+        </p:spPr>
+        <p:txBody>
+          <a:bodyPr wrap="square">
+            <a:spAutoFit/>
+          </a:bodyPr>
+          <a:lstStyle/>
+          <a:p>
+            <a:pPr>
+              <a:spcAft>
+                <a:spcPts val="1000"/>
+              </a:spcAft>
+              <a:defRPr sz="1500" b="0">
+                <a:solidFill>
+                  <a:srgbClr val="52525B"/>
+                </a:solidFill>
+              </a:defRPr>
+            </a:pPr>
+            <a:r>
+              <a:t>Running cost today: Cloud Run scales to zero; the demo runs on the GCP free-trial credit with a budget alert.</a:t>
+            </a:r>
+          </a:p>
+          <a:p>
+            <a:pPr>
+              <a:spcAft>
+                <a:spcPts val="1000"/>
+              </a:spcAft>
+              <a:defRPr sz="1500" b="0">
+                <a:solidFill>
+                  <a:srgbClr val="52525B"/>
+                </a:solidFill>
+              </a:defRPr>
+            </a:pPr>
+            <a:r>
+              <a:t>Firebase sign-in and Twilio WhatsApp are wired in code and are the pilot's two configuration steps.</a:t>
+            </a:r>
+          </a:p>
+        </p:txBody>
+      </p:sp>
+    </p:spTree>
+  </p:cSld>
+  <p:clrMapOvr>
+    <a:masterClrMapping/>
+  </p:clrMapOvr>
+</p:sld>
+</file>
+
+<file path=ppt/slides/slide12.xml><?xml version="1.0" encoding="utf-8"?>
+<p:sld xmlns:a="http://schemas.openxmlformats.org/drawingml/2006/main" xmlns:p="http://schemas.openxmlformats.org/presentationml/2006/main" xmlns:r="http://schemas.openxmlformats.org/officeDocument/2006/relationships">
+  <p:cSld>
+    <p:spTree>
+      <p:nvGrpSpPr>
+        <p:cNvPr id="1" name=""/>
+        <p:cNvGrpSpPr/>
+        <p:nvPr/>
+      </p:nvGrpSpPr>
+      <p:grpSpPr/>
+      <p:sp>
+        <p:nvSpPr>
+          <p:cNvPr id="2" name="Rectangle 1"/>
+          <p:cNvSpPr/>
+          <p:nvPr/>
+        </p:nvSpPr>
+        <p:spPr>
+          <a:xfrm>
+            <a:off x="0" y="0"/>
+            <a:ext cx="164592" cy="6858000"/>
+          </a:xfrm>
+          <a:prstGeom prst="rect">
+            <a:avLst/>
+          </a:prstGeom>
+          <a:solidFill>
+            <a:srgbClr val="0F766E"/>
+          </a:solidFill>
+          <a:ln>
+            <a:noFill/>
+          </a:ln>
+        </p:spPr>
+        <p:style>
+          <a:lnRef idx="1">
+            <a:schemeClr val="accent1"/>
+          </a:lnRef>
+          <a:fillRef idx="3">
+            <a:schemeClr val="accent1"/>
+          </a:fillRef>
+          <a:effectRef idx="2">
+            <a:schemeClr val="accent1"/>
+          </a:effectRef>
+          <a:fontRef idx="minor">
+            <a:schemeClr val="lt1"/>
+          </a:fontRef>
+        </p:style>
+        <p:txBody>
+          <a:bodyPr rtlCol="0" anchor="ctr"/>
+          <a:lstStyle/>
+          <a:p>
+            <a:pPr algn="ctr"/>
+          </a:p>
+        </p:txBody>
+      </p:sp>
+      <p:sp>
+        <p:nvSpPr>
+          <p:cNvPr id="3" name="TextBox 2"/>
+          <p:cNvSpPr txBox="1"/>
+          <p:nvPr/>
+        </p:nvSpPr>
+        <p:spPr>
+          <a:xfrm>
+            <a:off x="640080" y="411480"/>
+            <a:ext cx="10972800" cy="365760"/>
+          </a:xfrm>
+          <a:prstGeom prst="rect">
+            <a:avLst/>
+          </a:prstGeom>
+          <a:noFill/>
+        </p:spPr>
+        <p:txBody>
+          <a:bodyPr wrap="square">
+            <a:spAutoFit/>
+          </a:bodyPr>
+          <a:lstStyle/>
+          <a:p>
+            <a:pPr>
+              <a:spcAft>
+                <a:spcPts val="1000"/>
+              </a:spcAft>
+              <a:defRPr sz="1400" b="1">
+                <a:solidFill>
+                  <a:srgbClr val="0F766E"/>
+                </a:solidFill>
+              </a:defRPr>
+            </a:pPr>
+            <a:r>
+              <a:t>Tech</a:t>
+            </a:r>
+          </a:p>
+        </p:txBody>
+      </p:sp>
+      <p:sp>
+        <p:nvSpPr>
+          <p:cNvPr id="4" name="TextBox 3"/>
+          <p:cNvSpPr txBox="1"/>
+          <p:nvPr/>
+        </p:nvSpPr>
+        <p:spPr>
+          <a:xfrm>
+            <a:off x="640080" y="731520"/>
+            <a:ext cx="10972800" cy="914400"/>
+          </a:xfrm>
+          <a:prstGeom prst="rect">
+            <a:avLst/>
+          </a:prstGeom>
+          <a:noFill/>
+        </p:spPr>
+        <p:txBody>
+          <a:bodyPr wrap="square">
+            <a:spAutoFit/>
+          </a:bodyPr>
+          <a:lstStyle/>
+          <a:p>
+            <a:pPr>
+              <a:spcAft>
+                <a:spcPts val="1000"/>
+              </a:spcAft>
+              <a:defRPr sz="3400" b="1">
+                <a:solidFill>
+                  <a:srgbClr val="18181B"/>
+                </a:solidFill>
+              </a:defRPr>
+            </a:pPr>
+            <a:r>
+              <a:t>Running on Google Cloud</a:t>
+            </a:r>
+          </a:p>
+        </p:txBody>
+      </p:sp>
+      <p:sp>
+        <p:nvSpPr>
+          <p:cNvPr id="5" name="TextBox 4"/>
+          <p:cNvSpPr txBox="1"/>
+          <p:nvPr/>
+        </p:nvSpPr>
+        <p:spPr>
+          <a:xfrm>
+            <a:off x="640080" y="1828800"/>
+            <a:ext cx="10972800" cy="2743200"/>
+          </a:xfrm>
+          <a:prstGeom prst="rect">
+            <a:avLst/>
+          </a:prstGeom>
+          <a:noFill/>
+        </p:spPr>
+        <p:txBody>
+          <a:bodyPr wrap="square">
+            <a:spAutoFit/>
+          </a:bodyPr>
+          <a:lstStyle/>
+          <a:p>
+            <a:pPr>
+              <a:spcAft>
+                <a:spcPts val="1000"/>
+              </a:spcAft>
+              <a:defRPr sz="2000" b="0">
+                <a:solidFill>
+                  <a:srgbClr val="18181B"/>
+                </a:solidFill>
+              </a:defRPr>
+            </a:pPr>
+            <a:r>
+              <a:t>Cloud Run · Firestore · BigQuery · Pub/Sub · Cloud KMS · Secret Manager (Terraform)</a:t>
+            </a:r>
+          </a:p>
+          <a:p>
+            <a:pPr>
+              <a:spcAft>
+                <a:spcPts val="1000"/>
+              </a:spcAft>
+              <a:defRPr sz="2000" b="0">
+                <a:solidFill>
+                  <a:srgbClr val="18181B"/>
+                </a:solidFill>
+              </a:defRPr>
+            </a:pPr>
+            <a:r>
+              <a:t>Gemini (register photos) · Vertex AI embeddings · Google OR-Tools</a:t>
+            </a:r>
+          </a:p>
+          <a:p>
+            <a:pPr>
+              <a:spcAft>
+                <a:spcPts val="1000"/>
+              </a:spcAft>
+              <a:defRPr sz="2000" b="0">
+                <a:solidFill>
+                  <a:srgbClr val="18181B"/>
+                </a:solidFill>
+              </a:defRPr>
+            </a:pPr>
+            <a:r>
+              <a:t>LightGBM · FastAPI · Next.js 15 · 349 automated tests</a:t>
+            </a:r>
+          </a:p>
+        </p:txBody>
+      </p:sp>
+    </p:spTree>
+  </p:cSld>
+  <p:clrMapOvr>
+    <a:masterClrMapping/>
+  </p:clrMapOvr>
+</p:sld>
+</file>
+
+<file path=ppt/slides/slide13.xml><?xml version="1.0" encoding="utf-8"?>
 <p:sld xmlns:a="http://schemas.openxmlformats.org/drawingml/2006/main" xmlns:p="http://schemas.openxmlformats.org/presentationml/2006/main" xmlns:r="http://schemas.openxmlformats.org/officeDocument/2006/relationships">
   <p:cSld>
     <p:spTree>
@@ -6707,7 +7560,7 @@
               </a:defRPr>
             </a:pPr>
             <a:r>
-              <a:t>348</a:t>
+              <a:t>349</a:t>
             </a:r>
           </a:p>
         </p:txBody>
@@ -6742,7 +7595,7 @@
               </a:defRPr>
             </a:pPr>
             <a:r>
-              <a:t>automated tests (334 backend + 14 E2E, passing on Cloud Run)</a:t>
+              <a:t>automated tests (335 backend + 14 E2E, passing on Cloud Run)</a:t>
             </a:r>
           </a:p>
         </p:txBody>

</xml_diff>

<commit_message>
docs: 12-slide deck covering every topic the brief asks for; README, Q&A, demo script and HACKATHON.md on the judging weights
- Deck: added Who it serves, Across India and beyond (incl. BRICS), Pilot in 4 weeks; merged
  Multilingual into Nurse channel, Results into Impact, Tech into Pilot; new screenshots from
  the live site (voice card, morning briefing, agent, national reach).
- Forecast claims corrected: the app serves the last-week baseline per facility; LightGBM's 19%
  is the district-level real-HMIS result. README and deck no longer imply LightGBM runs per facility.
- HACKATHON.md: judging weights, 10-12 slide rule, rule 04, and the date conflict between the
  event page and the finalist email.
- Simulator help text mentions voice and photos; voice e2e feeds the mic through Web Audio
  (Chromium's fake capture device hangs headless on macOS).

Co-Authored-By: Claude Opus 5.5 <noreply@anthropic.com>
</commit_message>
<xml_diff>
--- a/docs/pitch/AushadhiNet-pitch.pptx
+++ b/docs/pitch/AushadhiNet-pitch.pptx
@@ -7,16 +7,15 @@
   <p:sldIdLst>
     <p:sldId id="256" r:id="rId7"/>
     <p:sldId id="257" r:id="rId8"/>
+    <p:sldId id="271" r:id="rId16"/>
     <p:sldId id="258" r:id="rId9"/>
     <p:sldId id="259" r:id="rId10"/>
-    <p:sldId id="260" r:id="rId11"/>
     <p:sldId id="261" r:id="rId12"/>
     <p:sldId id="262" r:id="rId13"/>
-    <p:sldId id="263" r:id="rId14"/>
+    <p:sldId id="269" r:id="rId18"/>
     <p:sldId id="267" r:id="rId15"/>
-    <p:sldId id="269" r:id="rId18"/>
+    <p:sldId id="272" r:id="rId14"/>
     <p:sldId id="270" r:id="rId19"/>
-    <p:sldId id="265" r:id="rId16"/>
     <p:sldId id="268" r:id="rId17"/>
   </p:sldIdLst>
   <p:sldSz cx="12191695" cy="6858000" type="screen4x3"/>
@@ -3312,14 +3311,14 @@
       </p:sp>
       <p:pic>
         <p:nvPicPr>
-          <p:cNvPr id="7" name="Picture 6" descr="s40.png"/>
+          <p:cNvPr id="7" name="Picture 6" descr="image.png"/>
           <p:cNvPicPr>
             <a:picLocks noChangeAspect="1"/>
           </p:cNvPicPr>
           <p:nvPr/>
         </p:nvPicPr>
         <p:blipFill>
-          <a:blip r:embed="rId2"/>
+          <a:blip r:embed="rId3"/>
           <a:stretch>
             <a:fillRect/>
           </a:stretch>
@@ -3428,7 +3427,7 @@
               </a:defRPr>
             </a:pPr>
             <a:r>
-              <a:t>Google AI in the loop</a:t>
+              <a:t>Across India, and beyond</a:t>
             </a:r>
           </a:p>
         </p:txBody>
@@ -3466,7 +3465,7 @@
               </a:defRPr>
             </a:pPr>
             <a:r>
-              <a:t>Gemini reads register photos</a:t>
+              <a:t>Every state is already in the system</a:t>
             </a:r>
           </a:p>
         </p:txBody>
@@ -3480,7 +3479,7 @@
         <p:spPr>
           <a:xfrm>
             <a:off x="640080" y="1828800"/>
-            <a:ext cx="3566160" cy="822960"/>
+            <a:ext cx="4023360" cy="3657600"/>
           </a:xfrm>
           <a:prstGeom prst="rect">
             <a:avLst/>
@@ -3497,276 +3496,102 @@
               <a:spcAft>
                 <a:spcPts val="1000"/>
               </a:spcAft>
-              <a:defRPr sz="4400" b="1">
-                <a:solidFill>
-                  <a:srgbClr val="0F766E"/>
-                </a:solidFill>
-              </a:defRPr>
-            </a:pPr>
-            <a:r>
-              <a:t>100%</a:t>
-            </a:r>
-          </a:p>
-        </p:txBody>
-      </p:sp>
-      <p:sp>
-        <p:nvSpPr>
-          <p:cNvPr id="6" name="TextBox 5"/>
-          <p:cNvSpPr txBox="1"/>
-          <p:nvPr/>
-        </p:nvSpPr>
-        <p:spPr>
-          <a:xfrm>
-            <a:off x="640080" y="2743200"/>
-            <a:ext cx="3566160" cy="731520"/>
-          </a:xfrm>
-          <a:prstGeom prst="rect">
-            <a:avLst/>
-          </a:prstGeom>
-          <a:noFill/>
-        </p:spPr>
-        <p:txBody>
-          <a:bodyPr wrap="square">
-            <a:spAutoFit/>
-          </a:bodyPr>
-          <a:lstStyle/>
+              <a:defRPr sz="1800" b="0">
+                <a:solidFill>
+                  <a:srgbClr val="18181B"/>
+                </a:solidFill>
+              </a:defRPr>
+            </a:pPr>
+            <a:r>
+              <a:t>1,90,609 facilities in 678 districts, 36 states and UTs (MoHFW directory)</a:t>
+            </a:r>
+          </a:p>
           <a:p>
             <a:pPr>
               <a:spcAft>
                 <a:spcPts val="1000"/>
               </a:spcAft>
-              <a:defRPr sz="1500" b="0">
-                <a:solidFill>
-                  <a:srgbClr val="52525B"/>
-                </a:solidFill>
-              </a:defRPr>
-            </a:pPr>
-            <a:r>
-              <a:t>quantity read correctly</a:t>
-            </a:r>
-          </a:p>
-        </p:txBody>
-      </p:sp>
-      <p:sp>
-        <p:nvSpPr>
-          <p:cNvPr id="7" name="TextBox 6"/>
-          <p:cNvSpPr txBox="1"/>
-          <p:nvPr/>
-        </p:nvSpPr>
-        <p:spPr>
-          <a:xfrm>
-            <a:off x="4389120" y="1828800"/>
-            <a:ext cx="3566160" cy="822960"/>
-          </a:xfrm>
-          <a:prstGeom prst="rect">
-            <a:avLst/>
-          </a:prstGeom>
-          <a:noFill/>
-        </p:spPr>
-        <p:txBody>
-          <a:bodyPr wrap="square">
-            <a:spAutoFit/>
-          </a:bodyPr>
-          <a:lstStyle/>
+              <a:defRPr sz="1800" b="0">
+                <a:solidFill>
+                  <a:srgbClr val="18181B"/>
+                </a:solidFill>
+              </a:defRPr>
+            </a:pPr>
+            <a:r>
+              <a:t>A district goes live with its nurses' WhatsApp numbers</a:t>
+            </a:r>
+          </a:p>
           <a:p>
             <a:pPr>
               <a:spcAft>
                 <a:spcPts val="1000"/>
               </a:spcAft>
-              <a:defRPr sz="4400" b="1">
-                <a:solidFill>
-                  <a:srgbClr val="0F766E"/>
-                </a:solidFill>
-              </a:defRPr>
-            </a:pPr>
-            <a:r>
-              <a:t>98.1%</a:t>
-            </a:r>
-          </a:p>
-        </p:txBody>
-      </p:sp>
-      <p:sp>
-        <p:nvSpPr>
-          <p:cNvPr id="8" name="TextBox 7"/>
-          <p:cNvSpPr txBox="1"/>
-          <p:nvPr/>
-        </p:nvSpPr>
-        <p:spPr>
-          <a:xfrm>
-            <a:off x="4389120" y="2743200"/>
-            <a:ext cx="3566160" cy="731520"/>
-          </a:xfrm>
-          <a:prstGeom prst="rect">
-            <a:avLst/>
-          </a:prstGeom>
-          <a:noFill/>
-        </p:spPr>
-        <p:txBody>
-          <a:bodyPr wrap="square">
-            <a:spAutoFit/>
-          </a:bodyPr>
-          <a:lstStyle/>
+              <a:defRPr sz="1800" b="0">
+                <a:solidFill>
+                  <a:srgbClr val="18181B"/>
+                </a:solidFill>
+              </a:defRPr>
+            </a:pPr>
+            <a:r>
+              <a:t>One Google Cloud project per state; data stays in-state</a:t>
+            </a:r>
+          </a:p>
           <a:p>
             <a:pPr>
               <a:spcAft>
                 <a:spcPts val="1000"/>
               </a:spcAft>
-              <a:defRPr sz="1500" b="0">
-                <a:solidFill>
-                  <a:srgbClr val="52525B"/>
-                </a:solidFill>
-              </a:defRPr>
-            </a:pPr>
-            <a:r>
-              <a:t>medicine matched</a:t>
-            </a:r>
-          </a:p>
-        </p:txBody>
-      </p:sp>
-      <p:sp>
-        <p:nvSpPr>
-          <p:cNvPr id="9" name="TextBox 8"/>
-          <p:cNvSpPr txBox="1"/>
-          <p:nvPr/>
-        </p:nvSpPr>
-        <p:spPr>
-          <a:xfrm>
-            <a:off x="8138159" y="1828800"/>
-            <a:ext cx="3566160" cy="822960"/>
-          </a:xfrm>
-          <a:prstGeom prst="rect">
-            <a:avLst/>
-          </a:prstGeom>
-          <a:noFill/>
-        </p:spPr>
-        <p:txBody>
-          <a:bodyPr wrap="square">
-            <a:spAutoFit/>
-          </a:bodyPr>
-          <a:lstStyle/>
+              <a:defRPr sz="1800" b="0">
+                <a:solidFill>
+                  <a:srgbClr val="18181B"/>
+                </a:solidFill>
+              </a:defRPr>
+            </a:pPr>
+            <a:r>
+              <a:t>Languages are data: a new one is a translation file</a:t>
+            </a:r>
+          </a:p>
           <a:p>
             <a:pPr>
               <a:spcAft>
                 <a:spcPts val="1000"/>
               </a:spcAft>
-              <a:defRPr sz="4400" b="1">
-                <a:solidFill>
-                  <a:srgbClr val="0F766E"/>
-                </a:solidFill>
-              </a:defRPr>
-            </a:pPr>
-            <a:r>
-              <a:t>4</a:t>
-            </a:r>
-          </a:p>
-        </p:txBody>
-      </p:sp>
-      <p:sp>
-        <p:nvSpPr>
-          <p:cNvPr id="10" name="TextBox 9"/>
-          <p:cNvSpPr txBox="1"/>
-          <p:nvPr/>
-        </p:nvSpPr>
-        <p:spPr>
-          <a:xfrm>
-            <a:off x="8138159" y="2743200"/>
-            <a:ext cx="3566160" cy="731520"/>
-          </a:xfrm>
-          <a:prstGeom prst="rect">
-            <a:avLst/>
-          </a:prstGeom>
-          <a:noFill/>
-        </p:spPr>
-        <p:txBody>
-          <a:bodyPr wrap="square">
-            <a:spAutoFit/>
-          </a:bodyPr>
-          <a:lstStyle/>
-          <a:p>
-            <a:pPr>
-              <a:spcAft>
-                <a:spcPts val="1000"/>
-              </a:spcAft>
-              <a:defRPr sz="1500" b="0">
-                <a:solidFill>
-                  <a:srgbClr val="52525B"/>
-                </a:solidFill>
-              </a:defRPr>
-            </a:pPr>
-            <a:r>
-              <a:t>scripts: English, Devanagari, Tamil, Bengali</a:t>
-            </a:r>
-          </a:p>
-        </p:txBody>
-      </p:sp>
-      <p:sp>
-        <p:nvSpPr>
-          <p:cNvPr id="11" name="TextBox 10"/>
-          <p:cNvSpPr txBox="1"/>
-          <p:nvPr/>
-        </p:nvSpPr>
-        <p:spPr>
-          <a:xfrm>
-            <a:off x="640080" y="3840480"/>
-            <a:ext cx="10972800" cy="2286000"/>
-          </a:xfrm>
-          <a:prstGeom prst="rect">
-            <a:avLst/>
-          </a:prstGeom>
-          <a:noFill/>
-        </p:spPr>
-        <p:txBody>
-          <a:bodyPr wrap="square">
-            <a:spAutoFit/>
-          </a:bodyPr>
-          <a:lstStyle/>
-          <a:p>
-            <a:pPr>
-              <a:spcAft>
-                <a:spcPts val="1000"/>
-              </a:spcAft>
-              <a:defRPr sz="1600" b="0">
+              <a:defRPr sz="1800" b="0">
                 <a:solidFill>
                   <a:srgbClr val="18181B"/>
                 </a:solidFill>
               </a:defRPr>
             </a:pPr>
             <a:r>
-              <a:t>Measured on 206 rendered register lines (synthetic text, not real handwriting photos).</a:t>
-            </a:r>
-          </a:p>
-          <a:p>
-            <a:pPr>
-              <a:spcAft>
-                <a:spcPts val="1000"/>
-              </a:spcAft>
-              <a:defRPr sz="1600" b="0">
-                <a:solidFill>
-                  <a:srgbClr val="18181B"/>
-                </a:solidFill>
-              </a:defRPr>
-            </a:pPr>
-            <a:r>
-              <a:t>Every photo read is confirmed by the nurse before it is saved: a model can be confidently wrong.</a:t>
-            </a:r>
-          </a:p>
-          <a:p>
-            <a:pPr>
-              <a:spcAft>
-                <a:spcPts val="1000"/>
-              </a:spcAft>
-              <a:defRPr sz="1600" b="0">
-                <a:solidFill>
-                  <a:srgbClr val="18181B"/>
-                </a:solidFill>
-              </a:defRPr>
-            </a:pPr>
-            <a:r>
-              <a:t>Next: measure on real register photos in the pilot.</a:t>
-            </a:r>
-          </a:p>
-        </p:txBody>
-      </p:sp>
+              <a:t>BRICS: swap the facility list, the WHO medicines list and the language</a:t>
+            </a:r>
+          </a:p>
+        </p:txBody>
+      </p:sp>
+      <p:pic>
+        <p:nvPicPr>
+          <p:cNvPr id="6" name="Picture 5" descr="india.png"/>
+          <p:cNvPicPr>
+            <a:picLocks noChangeAspect="1"/>
+          </p:cNvPicPr>
+          <p:nvPr/>
+        </p:nvPicPr>
+        <p:blipFill>
+          <a:blip r:embed="rId2"/>
+          <a:stretch>
+            <a:fillRect/>
+          </a:stretch>
+        </p:blipFill>
+        <p:spPr>
+          <a:xfrm>
+            <a:off x="4937760" y="1645920"/>
+            <a:ext cx="6949440" cy="3909060"/>
+          </a:xfrm>
+          <a:prstGeom prst="rect">
+            <a:avLst/>
+          </a:prstGeom>
+        </p:spPr>
+      </p:pic>
     </p:spTree>
   </p:cSld>
   <p:clrMapOvr>
@@ -3861,7 +3686,7 @@
               </a:defRPr>
             </a:pPr>
             <a:r>
-              <a:t>Rollout</a:t>
+              <a:t>Deployable</a:t>
             </a:r>
           </a:p>
         </p:txBody>
@@ -3899,7 +3724,7 @@
               </a:defRPr>
             </a:pPr>
             <a:r>
-              <a:t>From one block to a state, on Google Cloud</a:t>
+              <a:t>A pilot in 4 weeks, on Google Cloud</a:t>
             </a:r>
           </a:p>
         </p:txBody>
@@ -3937,7 +3762,7 @@
               </a:defRPr>
             </a:pPr>
             <a:r>
-              <a:t>Pilot</a:t>
+              <a:t>Weeks 1-2</a:t>
             </a:r>
           </a:p>
         </p:txBody>
@@ -3975,7 +3800,7 @@
               </a:defRPr>
             </a:pPr>
             <a:r>
-              <a:t>1 Nashik block: nurses' WhatsApp numbers, real register photos, 1 officer approving transfers</a:t>
+              <a:t>terraform apply creates the state's project (37 resources) and Cloud Build deploys: this one took a day. Load one block's nurse numbers; connect Twilio and Firebase sign-in.</a:t>
             </a:r>
           </a:p>
         </p:txBody>
@@ -4013,7 +3838,7 @@
               </a:defRPr>
             </a:pPr>
             <a:r>
-              <a:t>District</a:t>
+              <a:t>Week 3</a:t>
             </a:r>
           </a:p>
         </p:txBody>
@@ -4051,7 +3876,7 @@
               </a:defRPr>
             </a:pPr>
             <a:r>
-              <a:t>760 facilities: forecasts and transfer drafts weekly; measure stock-out weeks against last year</a:t>
+              <a:t>Nurses report daily by text, voice or photo. Real register photos measure extraction accuracy.</a:t>
             </a:r>
           </a:p>
         </p:txBody>
@@ -4089,7 +3914,7 @@
               </a:defRPr>
             </a:pPr>
             <a:r>
-              <a:t>State</a:t>
+              <a:t>Week 4</a:t>
             </a:r>
           </a:p>
         </p:txBody>
@@ -4127,7 +3952,7 @@
               </a:defRPr>
             </a:pPr>
             <a:r>
-              <a:t>One GCP project per state (Terraform), so raw facility data stays in the state; federated model updates only</a:t>
+              <a:t>The officer approves transfers and sends supply requests. Compare stock-out weeks with the same weeks last year.</a:t>
             </a:r>
           </a:p>
         </p:txBody>
@@ -4165,7 +3990,7 @@
               </a:defRPr>
             </a:pPr>
             <a:r>
-              <a:t>Running cost today: Cloud Run scales to zero; the demo runs on the GCP free-trial credit with a budget alert.</a:t>
+              <a:t>Cloud Run · Firestore · BigQuery · Pub/Sub · Cloud KMS · Secret Manager · Vertex AI · Gemini · Chirp 2, all from Terraform.</a:t>
             </a:r>
           </a:p>
           <a:p>
@@ -4180,7 +4005,7 @@
               </a:defRPr>
             </a:pPr>
             <a:r>
-              <a:t>Firebase sign-in and Twilio WhatsApp are wired in code and are the pilot's two configuration steps.</a:t>
+              <a:t>Cloud Run scales to zero; this deployment runs on the GCP free-trial credit with a budget alert.</a:t>
             </a:r>
           </a:p>
         </p:txBody>
@@ -4255,211 +4080,6 @@
         <p:spPr>
           <a:xfrm>
             <a:off x="640080" y="411480"/>
-            <a:ext cx="10972800" cy="365760"/>
-          </a:xfrm>
-          <a:prstGeom prst="rect">
-            <a:avLst/>
-          </a:prstGeom>
-          <a:noFill/>
-        </p:spPr>
-        <p:txBody>
-          <a:bodyPr wrap="square">
-            <a:spAutoFit/>
-          </a:bodyPr>
-          <a:lstStyle/>
-          <a:p>
-            <a:pPr>
-              <a:spcAft>
-                <a:spcPts val="1000"/>
-              </a:spcAft>
-              <a:defRPr sz="1400" b="1">
-                <a:solidFill>
-                  <a:srgbClr val="0F766E"/>
-                </a:solidFill>
-              </a:defRPr>
-            </a:pPr>
-            <a:r>
-              <a:t>Tech</a:t>
-            </a:r>
-          </a:p>
-        </p:txBody>
-      </p:sp>
-      <p:sp>
-        <p:nvSpPr>
-          <p:cNvPr id="4" name="TextBox 3"/>
-          <p:cNvSpPr txBox="1"/>
-          <p:nvPr/>
-        </p:nvSpPr>
-        <p:spPr>
-          <a:xfrm>
-            <a:off x="640080" y="731520"/>
-            <a:ext cx="10972800" cy="914400"/>
-          </a:xfrm>
-          <a:prstGeom prst="rect">
-            <a:avLst/>
-          </a:prstGeom>
-          <a:noFill/>
-        </p:spPr>
-        <p:txBody>
-          <a:bodyPr wrap="square">
-            <a:spAutoFit/>
-          </a:bodyPr>
-          <a:lstStyle/>
-          <a:p>
-            <a:pPr>
-              <a:spcAft>
-                <a:spcPts val="1000"/>
-              </a:spcAft>
-              <a:defRPr sz="3400" b="1">
-                <a:solidFill>
-                  <a:srgbClr val="18181B"/>
-                </a:solidFill>
-              </a:defRPr>
-            </a:pPr>
-            <a:r>
-              <a:t>Running on Google Cloud</a:t>
-            </a:r>
-          </a:p>
-        </p:txBody>
-      </p:sp>
-      <p:sp>
-        <p:nvSpPr>
-          <p:cNvPr id="5" name="TextBox 4"/>
-          <p:cNvSpPr txBox="1"/>
-          <p:nvPr/>
-        </p:nvSpPr>
-        <p:spPr>
-          <a:xfrm>
-            <a:off x="640080" y="1828800"/>
-            <a:ext cx="10972800" cy="2743200"/>
-          </a:xfrm>
-          <a:prstGeom prst="rect">
-            <a:avLst/>
-          </a:prstGeom>
-          <a:noFill/>
-        </p:spPr>
-        <p:txBody>
-          <a:bodyPr wrap="square">
-            <a:spAutoFit/>
-          </a:bodyPr>
-          <a:lstStyle/>
-          <a:p>
-            <a:pPr>
-              <a:spcAft>
-                <a:spcPts val="1000"/>
-              </a:spcAft>
-              <a:defRPr sz="2000" b="0">
-                <a:solidFill>
-                  <a:srgbClr val="18181B"/>
-                </a:solidFill>
-              </a:defRPr>
-            </a:pPr>
-            <a:r>
-              <a:t>Cloud Run · Firestore · BigQuery · Pub/Sub · Cloud KMS · Secret Manager (Terraform)</a:t>
-            </a:r>
-          </a:p>
-          <a:p>
-            <a:pPr>
-              <a:spcAft>
-                <a:spcPts val="1000"/>
-              </a:spcAft>
-              <a:defRPr sz="2000" b="0">
-                <a:solidFill>
-                  <a:srgbClr val="18181B"/>
-                </a:solidFill>
-              </a:defRPr>
-            </a:pPr>
-            <a:r>
-              <a:t>Gemini (register photos) · Vertex AI embeddings · Google OR-Tools</a:t>
-            </a:r>
-          </a:p>
-          <a:p>
-            <a:pPr>
-              <a:spcAft>
-                <a:spcPts val="1000"/>
-              </a:spcAft>
-              <a:defRPr sz="2000" b="0">
-                <a:solidFill>
-                  <a:srgbClr val="18181B"/>
-                </a:solidFill>
-              </a:defRPr>
-            </a:pPr>
-            <a:r>
-              <a:t>LightGBM · FastAPI · Next.js 15 · 349 automated tests</a:t>
-            </a:r>
-          </a:p>
-        </p:txBody>
-      </p:sp>
-    </p:spTree>
-  </p:cSld>
-  <p:clrMapOvr>
-    <a:masterClrMapping/>
-  </p:clrMapOvr>
-</p:sld>
-</file>
-
-<file path=ppt/slides/slide13.xml><?xml version="1.0" encoding="utf-8"?>
-<p:sld xmlns:a="http://schemas.openxmlformats.org/drawingml/2006/main" xmlns:p="http://schemas.openxmlformats.org/presentationml/2006/main" xmlns:r="http://schemas.openxmlformats.org/officeDocument/2006/relationships">
-  <p:cSld>
-    <p:spTree>
-      <p:nvGrpSpPr>
-        <p:cNvPr id="1" name=""/>
-        <p:cNvGrpSpPr/>
-        <p:nvPr/>
-      </p:nvGrpSpPr>
-      <p:grpSpPr/>
-      <p:sp>
-        <p:nvSpPr>
-          <p:cNvPr id="2" name="Rectangle 1"/>
-          <p:cNvSpPr/>
-          <p:nvPr/>
-        </p:nvSpPr>
-        <p:spPr>
-          <a:xfrm>
-            <a:off x="0" y="0"/>
-            <a:ext cx="164592" cy="6858000"/>
-          </a:xfrm>
-          <a:prstGeom prst="rect">
-            <a:avLst/>
-          </a:prstGeom>
-          <a:solidFill>
-            <a:srgbClr val="0F766E"/>
-          </a:solidFill>
-          <a:ln>
-            <a:noFill/>
-          </a:ln>
-        </p:spPr>
-        <p:style>
-          <a:lnRef idx="1">
-            <a:schemeClr val="accent1"/>
-          </a:lnRef>
-          <a:fillRef idx="3">
-            <a:schemeClr val="accent1"/>
-          </a:fillRef>
-          <a:effectRef idx="2">
-            <a:schemeClr val="accent1"/>
-          </a:effectRef>
-          <a:fontRef idx="minor">
-            <a:schemeClr val="lt1"/>
-          </a:fontRef>
-        </p:style>
-        <p:txBody>
-          <a:bodyPr rtlCol="0" anchor="ctr"/>
-          <a:lstStyle/>
-          <a:p>
-            <a:pPr algn="ctr"/>
-          </a:p>
-        </p:txBody>
-      </p:sp>
-      <p:sp>
-        <p:nvSpPr>
-          <p:cNvPr id="3" name="TextBox 2"/>
-          <p:cNvSpPr txBox="1"/>
-          <p:nvPr/>
-        </p:nvSpPr>
-        <p:spPr>
-          <a:xfrm>
-            <a:off x="640080" y="411480"/>
             <a:ext cx="10972800" cy="914400"/>
           </a:xfrm>
           <a:prstGeom prst="rect">
@@ -4905,7 +4525,7 @@
               </a:defRPr>
             </a:pPr>
             <a:r>
-              <a:t>How it works</a:t>
+              <a:t>Who it serves</a:t>
             </a:r>
           </a:p>
         </p:txBody>
@@ -4943,66 +4563,21 @@
               </a:defRPr>
             </a:pPr>
             <a:r>
-              <a:t>Report → Forecast → Rebalance → Human approves</a:t>
-            </a:r>
-          </a:p>
-        </p:txBody>
-      </p:sp>
-      <p:sp>
-        <p:nvSpPr>
-          <p:cNvPr id="5" name="Rounded Rectangle 4"/>
-          <p:cNvSpPr/>
-          <p:nvPr/>
-        </p:nvSpPr>
-        <p:spPr>
-          <a:xfrm>
-            <a:off x="640080" y="2011680"/>
-            <a:ext cx="2651760" cy="3108960"/>
-          </a:xfrm>
-          <a:prstGeom prst="roundRect">
-            <a:avLst/>
-          </a:prstGeom>
-          <a:solidFill>
-            <a:srgbClr val="F0FDFA"/>
-          </a:solidFill>
-          <a:ln>
-            <a:solidFill>
-              <a:srgbClr val="0F766E"/>
-            </a:solidFill>
-          </a:ln>
-        </p:spPr>
-        <p:style>
-          <a:lnRef idx="1">
-            <a:schemeClr val="accent1"/>
-          </a:lnRef>
-          <a:fillRef idx="3">
-            <a:schemeClr val="accent1"/>
-          </a:fillRef>
-          <a:effectRef idx="2">
-            <a:schemeClr val="accent1"/>
-          </a:effectRef>
-          <a:fontRef idx="minor">
-            <a:schemeClr val="lt1"/>
-          </a:fontRef>
-        </p:style>
-        <p:txBody>
-          <a:bodyPr rtlCol="0" anchor="ctr"/>
-          <a:lstStyle/>
-          <a:p>
-            <a:pPr algn="ctr"/>
-          </a:p>
-        </p:txBody>
-      </p:sp>
-      <p:sp>
-        <p:nvSpPr>
-          <p:cNvPr id="6" name="TextBox 5"/>
-          <p:cNvSpPr txBox="1"/>
-          <p:nvPr/>
-        </p:nvSpPr>
-        <p:spPr>
-          <a:xfrm>
-            <a:off x="822959" y="2194560"/>
-            <a:ext cx="2286000" cy="548640"/>
+              <a:t>Built around the district officer's morning</a:t>
+            </a:r>
+          </a:p>
+        </p:txBody>
+      </p:sp>
+      <p:sp>
+        <p:nvSpPr>
+          <p:cNvPr id="5" name="TextBox 4"/>
+          <p:cNvSpPr txBox="1"/>
+          <p:nvPr/>
+        </p:nvSpPr>
+        <p:spPr>
+          <a:xfrm>
+            <a:off x="640080" y="1828800"/>
+            <a:ext cx="3566160" cy="548640"/>
           </a:xfrm>
           <a:prstGeom prst="rect">
             <a:avLst/>
@@ -5019,28 +4594,28 @@
               <a:spcAft>
                 <a:spcPts val="1000"/>
               </a:spcAft>
-              <a:defRPr sz="2000" b="1">
+              <a:defRPr sz="2200" b="1">
                 <a:solidFill>
                   <a:srgbClr val="0F766E"/>
                 </a:solidFill>
               </a:defRPr>
             </a:pPr>
             <a:r>
-              <a:t>1  Report</a:t>
-            </a:r>
-          </a:p>
-        </p:txBody>
-      </p:sp>
-      <p:sp>
-        <p:nvSpPr>
-          <p:cNvPr id="7" name="TextBox 6"/>
-          <p:cNvSpPr txBox="1"/>
-          <p:nvPr/>
-        </p:nvSpPr>
-        <p:spPr>
-          <a:xfrm>
-            <a:off x="822959" y="2834640"/>
-            <a:ext cx="2286000" cy="2194560"/>
+              <a:t>District officer</a:t>
+            </a:r>
+          </a:p>
+        </p:txBody>
+      </p:sp>
+      <p:sp>
+        <p:nvSpPr>
+          <p:cNvPr id="6" name="TextBox 5"/>
+          <p:cNvSpPr txBox="1"/>
+          <p:nvPr/>
+        </p:nvSpPr>
+        <p:spPr>
+          <a:xfrm>
+            <a:off x="640080" y="2468880"/>
+            <a:ext cx="3474720" cy="2011680"/>
           </a:xfrm>
           <a:prstGeom prst="rect">
             <a:avLst/>
@@ -5064,66 +4639,21 @@
               </a:defRPr>
             </a:pPr>
             <a:r>
-              <a:t>Nurse sends stock on WhatsApp in 7 languages; unsure reads are confirmed first.</a:t>
-            </a:r>
-          </a:p>
-        </p:txBody>
-      </p:sp>
-      <p:sp>
-        <p:nvSpPr>
-          <p:cNvPr id="8" name="Rounded Rectangle 7"/>
-          <p:cNvSpPr/>
-          <p:nvPr/>
-        </p:nvSpPr>
-        <p:spPr>
-          <a:xfrm>
-            <a:off x="3474720" y="2011680"/>
-            <a:ext cx="2651760" cy="3108960"/>
-          </a:xfrm>
-          <a:prstGeom prst="roundRect">
-            <a:avLst/>
-          </a:prstGeom>
-          <a:solidFill>
-            <a:srgbClr val="F0FDFA"/>
-          </a:solidFill>
-          <a:ln>
-            <a:solidFill>
-              <a:srgbClr val="0F766E"/>
-            </a:solidFill>
-          </a:ln>
-        </p:spPr>
-        <p:style>
-          <a:lnRef idx="1">
-            <a:schemeClr val="accent1"/>
-          </a:lnRef>
-          <a:fillRef idx="3">
-            <a:schemeClr val="accent1"/>
-          </a:fillRef>
-          <a:effectRef idx="2">
-            <a:schemeClr val="accent1"/>
-          </a:effectRef>
-          <a:fontRef idx="minor">
-            <a:schemeClr val="lt1"/>
-          </a:fontRef>
-        </p:style>
-        <p:txBody>
-          <a:bodyPr rtlCol="0" anchor="ctr"/>
-          <a:lstStyle/>
-          <a:p>
-            <a:pPr algn="ctr"/>
-          </a:p>
-        </p:txBody>
-      </p:sp>
-      <p:sp>
-        <p:nvSpPr>
-          <p:cNvPr id="9" name="TextBox 8"/>
-          <p:cNvSpPr txBox="1"/>
-          <p:nvPr/>
-        </p:nvSpPr>
-        <p:spPr>
-          <a:xfrm>
-            <a:off x="3657600" y="2194560"/>
-            <a:ext cx="2286000" cy="548640"/>
+              <a:t>District health officer or pharmacist, on a laptop: what to escalate to the state, which transfers to approve, most urgent first.</a:t>
+            </a:r>
+          </a:p>
+        </p:txBody>
+      </p:sp>
+      <p:sp>
+        <p:nvSpPr>
+          <p:cNvPr id="7" name="TextBox 6"/>
+          <p:cNvSpPr txBox="1"/>
+          <p:nvPr/>
+        </p:nvSpPr>
+        <p:spPr>
+          <a:xfrm>
+            <a:off x="4389120" y="1828800"/>
+            <a:ext cx="3566160" cy="548640"/>
           </a:xfrm>
           <a:prstGeom prst="rect">
             <a:avLst/>
@@ -5140,28 +4670,28 @@
               <a:spcAft>
                 <a:spcPts val="1000"/>
               </a:spcAft>
-              <a:defRPr sz="2000" b="1">
+              <a:defRPr sz="2200" b="1">
                 <a:solidFill>
                   <a:srgbClr val="0F766E"/>
                 </a:solidFill>
               </a:defRPr>
             </a:pPr>
             <a:r>
-              <a:t>2  Forecast</a:t>
-            </a:r>
-          </a:p>
-        </p:txBody>
-      </p:sp>
-      <p:sp>
-        <p:nvSpPr>
-          <p:cNvPr id="10" name="TextBox 9"/>
-          <p:cNvSpPr txBox="1"/>
-          <p:nvPr/>
-        </p:nvSpPr>
-        <p:spPr>
-          <a:xfrm>
-            <a:off x="3657600" y="2834640"/>
-            <a:ext cx="2286000" cy="2194560"/>
+              <a:t>Nurse at the facility</a:t>
+            </a:r>
+          </a:p>
+        </p:txBody>
+      </p:sp>
+      <p:sp>
+        <p:nvSpPr>
+          <p:cNvPr id="8" name="TextBox 7"/>
+          <p:cNvSpPr txBox="1"/>
+          <p:nvPr/>
+        </p:nvSpPr>
+        <p:spPr>
+          <a:xfrm>
+            <a:off x="4389120" y="2468880"/>
+            <a:ext cx="3474720" cy="2011680"/>
           </a:xfrm>
           <a:prstGeom prst="rect">
             <a:avLst/>
@@ -5185,66 +4715,21 @@
               </a:defRPr>
             </a:pPr>
             <a:r>
-              <a:t>LightGBM predicts next-week demand and stock-out probability per medicine.</a:t>
-            </a:r>
-          </a:p>
-        </p:txBody>
-      </p:sp>
-      <p:sp>
-        <p:nvSpPr>
-          <p:cNvPr id="11" name="Rounded Rectangle 10"/>
-          <p:cNvSpPr/>
-          <p:nvPr/>
-        </p:nvSpPr>
-        <p:spPr>
-          <a:xfrm>
-            <a:off x="6309360" y="2011680"/>
-            <a:ext cx="2651760" cy="3108960"/>
-          </a:xfrm>
-          <a:prstGeom prst="roundRect">
-            <a:avLst/>
-          </a:prstGeom>
-          <a:solidFill>
-            <a:srgbClr val="F0FDFA"/>
-          </a:solidFill>
-          <a:ln>
-            <a:solidFill>
-              <a:srgbClr val="0F766E"/>
-            </a:solidFill>
-          </a:ln>
-        </p:spPr>
-        <p:style>
-          <a:lnRef idx="1">
-            <a:schemeClr val="accent1"/>
-          </a:lnRef>
-          <a:fillRef idx="3">
-            <a:schemeClr val="accent1"/>
-          </a:fillRef>
-          <a:effectRef idx="2">
-            <a:schemeClr val="accent1"/>
-          </a:effectRef>
-          <a:fontRef idx="minor">
-            <a:schemeClr val="lt1"/>
-          </a:fontRef>
-        </p:style>
-        <p:txBody>
-          <a:bodyPr rtlCol="0" anchor="ctr"/>
-          <a:lstStyle/>
-          <a:p>
-            <a:pPr algn="ctr"/>
-          </a:p>
-        </p:txBody>
-      </p:sp>
-      <p:sp>
-        <p:nvSpPr>
-          <p:cNvPr id="12" name="TextBox 11"/>
-          <p:cNvSpPr txBox="1"/>
-          <p:nvPr/>
-        </p:nvSpPr>
-        <p:spPr>
-          <a:xfrm>
-            <a:off x="6492240" y="2194560"/>
-            <a:ext cx="2286000" cy="548640"/>
+              <a:t>ANM, staff nurse or pharmacist at a PHC or sub-centre, on a basic Android phone: reports in 30 seconds on WhatsApp, in their own language.</a:t>
+            </a:r>
+          </a:p>
+        </p:txBody>
+      </p:sp>
+      <p:sp>
+        <p:nvSpPr>
+          <p:cNvPr id="9" name="TextBox 8"/>
+          <p:cNvSpPr txBox="1"/>
+          <p:nvPr/>
+        </p:nvSpPr>
+        <p:spPr>
+          <a:xfrm>
+            <a:off x="8138159" y="1828800"/>
+            <a:ext cx="3566160" cy="548640"/>
           </a:xfrm>
           <a:prstGeom prst="rect">
             <a:avLst/>
@@ -5261,28 +4746,28 @@
               <a:spcAft>
                 <a:spcPts val="1000"/>
               </a:spcAft>
-              <a:defRPr sz="2000" b="1">
+              <a:defRPr sz="2200" b="1">
                 <a:solidFill>
                   <a:srgbClr val="0F766E"/>
                 </a:solidFill>
               </a:defRPr>
             </a:pPr>
             <a:r>
-              <a:t>3  Rebalance</a:t>
-            </a:r>
-          </a:p>
-        </p:txBody>
-      </p:sp>
-      <p:sp>
-        <p:nvSpPr>
-          <p:cNvPr id="13" name="TextBox 12"/>
-          <p:cNvSpPr txBox="1"/>
-          <p:nvPr/>
-        </p:nvSpPr>
-        <p:spPr>
-          <a:xfrm>
-            <a:off x="6492240" y="2834640"/>
-            <a:ext cx="2286000" cy="2194560"/>
+              <a:t>Public and planners</a:t>
+            </a:r>
+          </a:p>
+        </p:txBody>
+      </p:sp>
+      <p:sp>
+        <p:nvSpPr>
+          <p:cNvPr id="10" name="TextBox 9"/>
+          <p:cNvSpPr txBox="1"/>
+          <p:nvPr/>
+        </p:nvSpPr>
+        <p:spPr>
+          <a:xfrm>
+            <a:off x="8138159" y="2468880"/>
+            <a:ext cx="3474720" cy="2011680"/>
           </a:xfrm>
           <a:prstGeom prst="rect">
             <a:avLst/>
@@ -5306,104 +4791,21 @@
               </a:defRPr>
             </a:pPr>
             <a:r>
-              <a:t>Google OR-Tools proposes transfers from nearby surplus to at-risk facilities.</a:t>
-            </a:r>
-          </a:p>
-        </p:txBody>
-      </p:sp>
-      <p:sp>
-        <p:nvSpPr>
-          <p:cNvPr id="14" name="Rounded Rectangle 13"/>
-          <p:cNvSpPr/>
-          <p:nvPr/>
-        </p:nvSpPr>
-        <p:spPr>
-          <a:xfrm>
-            <a:off x="9144000" y="2011680"/>
-            <a:ext cx="2651760" cy="3108960"/>
-          </a:xfrm>
-          <a:prstGeom prst="roundRect">
-            <a:avLst/>
-          </a:prstGeom>
-          <a:solidFill>
-            <a:srgbClr val="F0FDFA"/>
-          </a:solidFill>
-          <a:ln>
-            <a:solidFill>
-              <a:srgbClr val="0F766E"/>
-            </a:solidFill>
-          </a:ln>
-        </p:spPr>
-        <p:style>
-          <a:lnRef idx="1">
-            <a:schemeClr val="accent1"/>
-          </a:lnRef>
-          <a:fillRef idx="3">
-            <a:schemeClr val="accent1"/>
-          </a:fillRef>
-          <a:effectRef idx="2">
-            <a:schemeClr val="accent1"/>
-          </a:effectRef>
-          <a:fontRef idx="minor">
-            <a:schemeClr val="lt1"/>
-          </a:fontRef>
-        </p:style>
-        <p:txBody>
-          <a:bodyPr rtlCol="0" anchor="ctr"/>
-          <a:lstStyle/>
-          <a:p>
-            <a:pPr algn="ctr"/>
-          </a:p>
-        </p:txBody>
-      </p:sp>
-      <p:sp>
-        <p:nvSpPr>
-          <p:cNvPr id="15" name="TextBox 14"/>
-          <p:cNvSpPr txBox="1"/>
-          <p:nvPr/>
-        </p:nvSpPr>
-        <p:spPr>
-          <a:xfrm>
-            <a:off x="9326880" y="2194560"/>
-            <a:ext cx="2286000" cy="548640"/>
-          </a:xfrm>
-          <a:prstGeom prst="rect">
-            <a:avLst/>
-          </a:prstGeom>
-          <a:noFill/>
-        </p:spPr>
-        <p:txBody>
-          <a:bodyPr wrap="square">
-            <a:spAutoFit/>
-          </a:bodyPr>
-          <a:lstStyle/>
-          <a:p>
-            <a:pPr>
-              <a:spcAft>
-                <a:spcPts val="1000"/>
-              </a:spcAft>
-              <a:defRPr sz="2000" b="1">
-                <a:solidFill>
-                  <a:srgbClr val="0F766E"/>
-                </a:solidFill>
-              </a:defRPr>
-            </a:pPr>
-            <a:r>
-              <a:t>4  Approve</a:t>
-            </a:r>
-          </a:p>
-        </p:txBody>
-      </p:sp>
-      <p:sp>
-        <p:nvSpPr>
-          <p:cNvPr id="16" name="TextBox 15"/>
-          <p:cNvSpPr txBox="1"/>
-          <p:nvPr/>
-        </p:nvSpPr>
-        <p:spPr>
-          <a:xfrm>
-            <a:off x="9326880" y="2834640"/>
-            <a:ext cx="2286000" cy="2194560"/>
+              <a:t>Citizens see district shortage totals, never a facility name. State planners see where to roll out next.</a:t>
+            </a:r>
+          </a:p>
+        </p:txBody>
+      </p:sp>
+      <p:sp>
+        <p:nvSpPr>
+          <p:cNvPr id="11" name="TextBox 10"/>
+          <p:cNvSpPr txBox="1"/>
+          <p:nvPr/>
+        </p:nvSpPr>
+        <p:spPr>
+          <a:xfrm>
+            <a:off x="640080" y="4754880"/>
+            <a:ext cx="10972800" cy="1463040"/>
           </a:xfrm>
           <a:prstGeom prst="rect">
             <a:avLst/>
@@ -5422,12 +4824,12 @@
               </a:spcAft>
               <a:defRPr sz="1500" b="0">
                 <a:solidFill>
-                  <a:srgbClr val="18181B"/>
-                </a:solidFill>
-              </a:defRPr>
-            </a:pPr>
-            <a:r>
-              <a:t>Officer approves; both facilities notified. The AI agent can explain and draft, never approve.</a:t>
+                  <a:srgbClr val="52525B"/>
+                </a:solidFill>
+              </a:defRPr>
+            </a:pPr>
+            <a:r>
+              <a:t>The nurse never opens the website: WhatsApp is the interface. The officer gets decisions, not dashboards.</a:t>
             </a:r>
           </a:p>
         </p:txBody>
@@ -5526,7 +4928,7 @@
               </a:defRPr>
             </a:pPr>
             <a:r>
-              <a:t>Nurse channel</a:t>
+              <a:t>How it works</a:t>
             </a:r>
           </a:p>
         </p:txBody>
@@ -5564,21 +4966,66 @@
               </a:defRPr>
             </a:pPr>
             <a:r>
-              <a:t>WhatsApp, no new app</a:t>
-            </a:r>
-          </a:p>
-        </p:txBody>
-      </p:sp>
-      <p:sp>
-        <p:nvSpPr>
-          <p:cNvPr id="5" name="TextBox 4"/>
-          <p:cNvSpPr txBox="1"/>
-          <p:nvPr/>
-        </p:nvSpPr>
-        <p:spPr>
-          <a:xfrm>
-            <a:off x="640080" y="1828800"/>
-            <a:ext cx="4023360" cy="3657600"/>
+              <a:t>Report → Forecast → Rebalance → Human approves</a:t>
+            </a:r>
+          </a:p>
+        </p:txBody>
+      </p:sp>
+      <p:sp>
+        <p:nvSpPr>
+          <p:cNvPr id="5" name="Rounded Rectangle 4"/>
+          <p:cNvSpPr/>
+          <p:nvPr/>
+        </p:nvSpPr>
+        <p:spPr>
+          <a:xfrm>
+            <a:off x="640080" y="2011680"/>
+            <a:ext cx="2651760" cy="3108960"/>
+          </a:xfrm>
+          <a:prstGeom prst="roundRect">
+            <a:avLst/>
+          </a:prstGeom>
+          <a:solidFill>
+            <a:srgbClr val="F0FDFA"/>
+          </a:solidFill>
+          <a:ln>
+            <a:solidFill>
+              <a:srgbClr val="0F766E"/>
+            </a:solidFill>
+          </a:ln>
+        </p:spPr>
+        <p:style>
+          <a:lnRef idx="1">
+            <a:schemeClr val="accent1"/>
+          </a:lnRef>
+          <a:fillRef idx="3">
+            <a:schemeClr val="accent1"/>
+          </a:fillRef>
+          <a:effectRef idx="2">
+            <a:schemeClr val="accent1"/>
+          </a:effectRef>
+          <a:fontRef idx="minor">
+            <a:schemeClr val="lt1"/>
+          </a:fontRef>
+        </p:style>
+        <p:txBody>
+          <a:bodyPr rtlCol="0" anchor="ctr"/>
+          <a:lstStyle/>
+          <a:p>
+            <a:pPr algn="ctr"/>
+          </a:p>
+        </p:txBody>
+      </p:sp>
+      <p:sp>
+        <p:nvSpPr>
+          <p:cNvPr id="6" name="TextBox 5"/>
+          <p:cNvSpPr txBox="1"/>
+          <p:nvPr/>
+        </p:nvSpPr>
+        <p:spPr>
+          <a:xfrm>
+            <a:off x="822959" y="2194560"/>
+            <a:ext cx="2286000" cy="548640"/>
           </a:xfrm>
           <a:prstGeom prst="rect">
             <a:avLst/>
@@ -5595,72 +5042,419 @@
               <a:spcAft>
                 <a:spcPts val="1000"/>
               </a:spcAft>
-              <a:defRPr sz="1800" b="0">
-                <a:solidFill>
-                  <a:srgbClr val="18181B"/>
-                </a:solidFill>
-              </a:defRPr>
-            </a:pPr>
-            <a:r>
-              <a:t>Text in any script, or a photo of the register</a:t>
-            </a:r>
-          </a:p>
+              <a:defRPr sz="2000" b="1">
+                <a:solidFill>
+                  <a:srgbClr val="0F766E"/>
+                </a:solidFill>
+              </a:defRPr>
+            </a:pPr>
+            <a:r>
+              <a:t>1  Report</a:t>
+            </a:r>
+          </a:p>
+        </p:txBody>
+      </p:sp>
+      <p:sp>
+        <p:nvSpPr>
+          <p:cNvPr id="7" name="TextBox 6"/>
+          <p:cNvSpPr txBox="1"/>
+          <p:nvPr/>
+        </p:nvSpPr>
+        <p:spPr>
+          <a:xfrm>
+            <a:off x="822959" y="2834640"/>
+            <a:ext cx="2286000" cy="2194560"/>
+          </a:xfrm>
+          <a:prstGeom prst="rect">
+            <a:avLst/>
+          </a:prstGeom>
+          <a:noFill/>
+        </p:spPr>
+        <p:txBody>
+          <a:bodyPr wrap="square">
+            <a:spAutoFit/>
+          </a:bodyPr>
+          <a:lstStyle/>
           <a:p>
             <a:pPr>
               <a:spcAft>
                 <a:spcPts val="1000"/>
               </a:spcAft>
-              <a:defRPr sz="1800" b="0">
+              <a:defRPr sz="1500" b="0">
                 <a:solidFill>
                   <a:srgbClr val="18181B"/>
                 </a:solidFill>
               </a:defRPr>
             </a:pPr>
             <a:r>
-              <a:t>Gemini reads every line of a photo</a:t>
-            </a:r>
-          </a:p>
+              <a:t>Nurse sends stock on WhatsApp by text, voice note or register photo, in 7 languages; every machine read is confirmed.</a:t>
+            </a:r>
+          </a:p>
+        </p:txBody>
+      </p:sp>
+      <p:sp>
+        <p:nvSpPr>
+          <p:cNvPr id="8" name="Rounded Rectangle 7"/>
+          <p:cNvSpPr/>
+          <p:nvPr/>
+        </p:nvSpPr>
+        <p:spPr>
+          <a:xfrm>
+            <a:off x="3474720" y="2011680"/>
+            <a:ext cx="2651760" cy="3108960"/>
+          </a:xfrm>
+          <a:prstGeom prst="roundRect">
+            <a:avLst/>
+          </a:prstGeom>
+          <a:solidFill>
+            <a:srgbClr val="F0FDFA"/>
+          </a:solidFill>
+          <a:ln>
+            <a:solidFill>
+              <a:srgbClr val="0F766E"/>
+            </a:solidFill>
+          </a:ln>
+        </p:spPr>
+        <p:style>
+          <a:lnRef idx="1">
+            <a:schemeClr val="accent1"/>
+          </a:lnRef>
+          <a:fillRef idx="3">
+            <a:schemeClr val="accent1"/>
+          </a:fillRef>
+          <a:effectRef idx="2">
+            <a:schemeClr val="accent1"/>
+          </a:effectRef>
+          <a:fontRef idx="minor">
+            <a:schemeClr val="lt1"/>
+          </a:fontRef>
+        </p:style>
+        <p:txBody>
+          <a:bodyPr rtlCol="0" anchor="ctr"/>
+          <a:lstStyle/>
+          <a:p>
+            <a:pPr algn="ctr"/>
+          </a:p>
+        </p:txBody>
+      </p:sp>
+      <p:sp>
+        <p:nvSpPr>
+          <p:cNvPr id="9" name="TextBox 8"/>
+          <p:cNvSpPr txBox="1"/>
+          <p:nvPr/>
+        </p:nvSpPr>
+        <p:spPr>
+          <a:xfrm>
+            <a:off x="3657600" y="2194560"/>
+            <a:ext cx="2286000" cy="548640"/>
+          </a:xfrm>
+          <a:prstGeom prst="rect">
+            <a:avLst/>
+          </a:prstGeom>
+          <a:noFill/>
+        </p:spPr>
+        <p:txBody>
+          <a:bodyPr wrap="square">
+            <a:spAutoFit/>
+          </a:bodyPr>
+          <a:lstStyle/>
           <a:p>
             <a:pPr>
               <a:spcAft>
                 <a:spcPts val="1000"/>
               </a:spcAft>
-              <a:defRPr sz="1800" b="0">
+              <a:defRPr sz="2000" b="1">
+                <a:solidFill>
+                  <a:srgbClr val="0F766E"/>
+                </a:solidFill>
+              </a:defRPr>
+            </a:pPr>
+            <a:r>
+              <a:t>2  Forecast</a:t>
+            </a:r>
+          </a:p>
+        </p:txBody>
+      </p:sp>
+      <p:sp>
+        <p:nvSpPr>
+          <p:cNvPr id="10" name="TextBox 9"/>
+          <p:cNvSpPr txBox="1"/>
+          <p:nvPr/>
+        </p:nvSpPr>
+        <p:spPr>
+          <a:xfrm>
+            <a:off x="3657600" y="2834640"/>
+            <a:ext cx="2286000" cy="2194560"/>
+          </a:xfrm>
+          <a:prstGeom prst="rect">
+            <a:avLst/>
+          </a:prstGeom>
+          <a:noFill/>
+        </p:spPr>
+        <p:txBody>
+          <a:bodyPr wrap="square">
+            <a:spAutoFit/>
+          </a:bodyPr>
+          <a:lstStyle/>
+          <a:p>
+            <a:pPr>
+              <a:spcAft>
+                <a:spcPts val="1000"/>
+              </a:spcAft>
+              <a:defRPr sz="1500" b="0">
                 <a:solidFill>
                   <a:srgbClr val="18181B"/>
                 </a:solidFill>
               </a:defRPr>
             </a:pPr>
             <a:r>
-              <a:t>Nothing is saved until the nurse confirms</a:t>
-            </a:r>
-          </a:p>
-        </p:txBody>
-      </p:sp>
-      <p:pic>
-        <p:nvPicPr>
-          <p:cNvPr id="6" name="Picture 5" descr="s55.png"/>
-          <p:cNvPicPr>
-            <a:picLocks noChangeAspect="1"/>
-          </p:cNvPicPr>
-          <p:nvPr/>
-        </p:nvPicPr>
-        <p:blipFill>
-          <a:blip r:embed="rId3"/>
-          <a:stretch>
-            <a:fillRect/>
-          </a:stretch>
-        </p:blipFill>
-        <p:spPr>
-          <a:xfrm>
-            <a:off x="4937760" y="1645920"/>
-            <a:ext cx="6949440" cy="3909060"/>
-          </a:xfrm>
-          <a:prstGeom prst="rect">
-            <a:avLst/>
-          </a:prstGeom>
-        </p:spPr>
-      </p:pic>
+              <a:t>Next-week demand and stock-out probability per facility and medicine; model chosen by measurement on real HMIS data.</a:t>
+            </a:r>
+          </a:p>
+        </p:txBody>
+      </p:sp>
+      <p:sp>
+        <p:nvSpPr>
+          <p:cNvPr id="11" name="Rounded Rectangle 10"/>
+          <p:cNvSpPr/>
+          <p:nvPr/>
+        </p:nvSpPr>
+        <p:spPr>
+          <a:xfrm>
+            <a:off x="6309360" y="2011680"/>
+            <a:ext cx="2651760" cy="3108960"/>
+          </a:xfrm>
+          <a:prstGeom prst="roundRect">
+            <a:avLst/>
+          </a:prstGeom>
+          <a:solidFill>
+            <a:srgbClr val="F0FDFA"/>
+          </a:solidFill>
+          <a:ln>
+            <a:solidFill>
+              <a:srgbClr val="0F766E"/>
+            </a:solidFill>
+          </a:ln>
+        </p:spPr>
+        <p:style>
+          <a:lnRef idx="1">
+            <a:schemeClr val="accent1"/>
+          </a:lnRef>
+          <a:fillRef idx="3">
+            <a:schemeClr val="accent1"/>
+          </a:fillRef>
+          <a:effectRef idx="2">
+            <a:schemeClr val="accent1"/>
+          </a:effectRef>
+          <a:fontRef idx="minor">
+            <a:schemeClr val="lt1"/>
+          </a:fontRef>
+        </p:style>
+        <p:txBody>
+          <a:bodyPr rtlCol="0" anchor="ctr"/>
+          <a:lstStyle/>
+          <a:p>
+            <a:pPr algn="ctr"/>
+          </a:p>
+        </p:txBody>
+      </p:sp>
+      <p:sp>
+        <p:nvSpPr>
+          <p:cNvPr id="12" name="TextBox 11"/>
+          <p:cNvSpPr txBox="1"/>
+          <p:nvPr/>
+        </p:nvSpPr>
+        <p:spPr>
+          <a:xfrm>
+            <a:off x="6492240" y="2194560"/>
+            <a:ext cx="2286000" cy="548640"/>
+          </a:xfrm>
+          <a:prstGeom prst="rect">
+            <a:avLst/>
+          </a:prstGeom>
+          <a:noFill/>
+        </p:spPr>
+        <p:txBody>
+          <a:bodyPr wrap="square">
+            <a:spAutoFit/>
+          </a:bodyPr>
+          <a:lstStyle/>
+          <a:p>
+            <a:pPr>
+              <a:spcAft>
+                <a:spcPts val="1000"/>
+              </a:spcAft>
+              <a:defRPr sz="2000" b="1">
+                <a:solidFill>
+                  <a:srgbClr val="0F766E"/>
+                </a:solidFill>
+              </a:defRPr>
+            </a:pPr>
+            <a:r>
+              <a:t>3  Rebalance or escalate</a:t>
+            </a:r>
+          </a:p>
+        </p:txBody>
+      </p:sp>
+      <p:sp>
+        <p:nvSpPr>
+          <p:cNvPr id="13" name="TextBox 12"/>
+          <p:cNvSpPr txBox="1"/>
+          <p:nvPr/>
+        </p:nvSpPr>
+        <p:spPr>
+          <a:xfrm>
+            <a:off x="6492240" y="2834640"/>
+            <a:ext cx="2286000" cy="2194560"/>
+          </a:xfrm>
+          <a:prstGeom prst="rect">
+            <a:avLst/>
+          </a:prstGeom>
+          <a:noFill/>
+        </p:spPr>
+        <p:txBody>
+          <a:bodyPr wrap="square">
+            <a:spAutoFit/>
+          </a:bodyPr>
+          <a:lstStyle/>
+          <a:p>
+            <a:pPr>
+              <a:spcAft>
+                <a:spcPts val="1000"/>
+              </a:spcAft>
+              <a:defRPr sz="1500" b="0">
+                <a:solidFill>
+                  <a:srgbClr val="18181B"/>
+                </a:solidFill>
+              </a:defRPr>
+            </a:pPr>
+            <a:r>
+              <a:t>OR-Tools drafts transfers from nearby surplus. Medicines short district-wide go to the state as a supply request.</a:t>
+            </a:r>
+          </a:p>
+        </p:txBody>
+      </p:sp>
+      <p:sp>
+        <p:nvSpPr>
+          <p:cNvPr id="14" name="Rounded Rectangle 13"/>
+          <p:cNvSpPr/>
+          <p:nvPr/>
+        </p:nvSpPr>
+        <p:spPr>
+          <a:xfrm>
+            <a:off x="9144000" y="2011680"/>
+            <a:ext cx="2651760" cy="3108960"/>
+          </a:xfrm>
+          <a:prstGeom prst="roundRect">
+            <a:avLst/>
+          </a:prstGeom>
+          <a:solidFill>
+            <a:srgbClr val="F0FDFA"/>
+          </a:solidFill>
+          <a:ln>
+            <a:solidFill>
+              <a:srgbClr val="0F766E"/>
+            </a:solidFill>
+          </a:ln>
+        </p:spPr>
+        <p:style>
+          <a:lnRef idx="1">
+            <a:schemeClr val="accent1"/>
+          </a:lnRef>
+          <a:fillRef idx="3">
+            <a:schemeClr val="accent1"/>
+          </a:fillRef>
+          <a:effectRef idx="2">
+            <a:schemeClr val="accent1"/>
+          </a:effectRef>
+          <a:fontRef idx="minor">
+            <a:schemeClr val="lt1"/>
+          </a:fontRef>
+        </p:style>
+        <p:txBody>
+          <a:bodyPr rtlCol="0" anchor="ctr"/>
+          <a:lstStyle/>
+          <a:p>
+            <a:pPr algn="ctr"/>
+          </a:p>
+        </p:txBody>
+      </p:sp>
+      <p:sp>
+        <p:nvSpPr>
+          <p:cNvPr id="15" name="TextBox 14"/>
+          <p:cNvSpPr txBox="1"/>
+          <p:nvPr/>
+        </p:nvSpPr>
+        <p:spPr>
+          <a:xfrm>
+            <a:off x="9326880" y="2194560"/>
+            <a:ext cx="2286000" cy="548640"/>
+          </a:xfrm>
+          <a:prstGeom prst="rect">
+            <a:avLst/>
+          </a:prstGeom>
+          <a:noFill/>
+        </p:spPr>
+        <p:txBody>
+          <a:bodyPr wrap="square">
+            <a:spAutoFit/>
+          </a:bodyPr>
+          <a:lstStyle/>
+          <a:p>
+            <a:pPr>
+              <a:spcAft>
+                <a:spcPts val="1000"/>
+              </a:spcAft>
+              <a:defRPr sz="2000" b="1">
+                <a:solidFill>
+                  <a:srgbClr val="0F766E"/>
+                </a:solidFill>
+              </a:defRPr>
+            </a:pPr>
+            <a:r>
+              <a:t>4  Approve</a:t>
+            </a:r>
+          </a:p>
+        </p:txBody>
+      </p:sp>
+      <p:sp>
+        <p:nvSpPr>
+          <p:cNvPr id="16" name="TextBox 15"/>
+          <p:cNvSpPr txBox="1"/>
+          <p:nvPr/>
+        </p:nvSpPr>
+        <p:spPr>
+          <a:xfrm>
+            <a:off x="9326880" y="2834640"/>
+            <a:ext cx="2286000" cy="2194560"/>
+          </a:xfrm>
+          <a:prstGeom prst="rect">
+            <a:avLst/>
+          </a:prstGeom>
+          <a:noFill/>
+        </p:spPr>
+        <p:txBody>
+          <a:bodyPr wrap="square">
+            <a:spAutoFit/>
+          </a:bodyPr>
+          <a:lstStyle/>
+          <a:p>
+            <a:pPr>
+              <a:spcAft>
+                <a:spcPts val="1000"/>
+              </a:spcAft>
+              <a:defRPr sz="1500" b="0">
+                <a:solidFill>
+                  <a:srgbClr val="18181B"/>
+                </a:solidFill>
+              </a:defRPr>
+            </a:pPr>
+            <a:r>
+              <a:t>Officer approves; signed order to both facilities. The AI agent explains and drafts, never approves.</a:t>
+            </a:r>
+          </a:p>
+        </p:txBody>
+      </p:sp>
     </p:spTree>
   </p:cSld>
   <p:clrMapOvr>
@@ -5755,7 +5549,7 @@
               </a:defRPr>
             </a:pPr>
             <a:r>
-              <a:t>Multilingual</a:t>
+              <a:t>Nurse channel</a:t>
             </a:r>
           </a:p>
         </p:txBody>
@@ -5793,7 +5587,7 @@
               </a:defRPr>
             </a:pPr>
             <a:r>
-              <a:t>Seven Indian languages</a:t>
+              <a:t>WhatsApp, 7 languages, no new app</a:t>
             </a:r>
           </a:p>
         </p:txBody>
@@ -5831,7 +5625,7 @@
               </a:defRPr>
             </a:pPr>
             <a:r>
-              <a:t>English, Hindi, Marathi, Bengali, Tamil, Telugu, Kannada</a:t>
+              <a:t>Text, a voice note or a photo of the register</a:t>
             </a:r>
           </a:p>
           <a:p>
@@ -5846,7 +5640,7 @@
               </a:defRPr>
             </a:pPr>
             <a:r>
-              <a:t>UI, medicine names, replies and agent answers</a:t>
+              <a:t>Chirp 2 hears the note and detects the language; Gemini reads every line of a photo</a:t>
             </a:r>
           </a:p>
           <a:p>
@@ -5861,21 +5655,51 @@
               </a:defRPr>
             </a:pPr>
             <a:r>
-              <a:t>Translations need native-speaker review</a:t>
+              <a:t>Several items in one message: “ORS 50 Zinc 120”</a:t>
+            </a:r>
+          </a:p>
+          <a:p>
+            <a:pPr>
+              <a:spcAft>
+                <a:spcPts val="1000"/>
+              </a:spcAft>
+              <a:defRPr sz="1800" b="0">
+                <a:solidFill>
+                  <a:srgbClr val="18181B"/>
+                </a:solidFill>
+              </a:defRPr>
+            </a:pPr>
+            <a:r>
+              <a:t>Nothing is saved until the nurse replies YES</a:t>
+            </a:r>
+          </a:p>
+          <a:p>
+            <a:pPr>
+              <a:spcAft>
+                <a:spcPts val="1000"/>
+              </a:spcAft>
+              <a:defRPr sz="1800" b="0">
+                <a:solidFill>
+                  <a:srgbClr val="18181B"/>
+                </a:solidFill>
+              </a:defRPr>
+            </a:pPr>
+            <a:r>
+              <a:t>English, Hindi, Marathi, Bengali, Tamil, Telugu, Kannada</a:t>
             </a:r>
           </a:p>
         </p:txBody>
       </p:sp>
       <p:pic>
         <p:nvPicPr>
-          <p:cNvPr id="6" name="Picture 5" descr="s78.png"/>
+          <p:cNvPr id="6" name="Picture 5" descr="nurse.png"/>
           <p:cNvPicPr>
             <a:picLocks noChangeAspect="1"/>
           </p:cNvPicPr>
           <p:nvPr/>
         </p:nvPicPr>
         <p:blipFill>
-          <a:blip r:embed="rId3"/>
+          <a:blip r:embed="rId4"/>
           <a:stretch>
             <a:fillRect/>
           </a:stretch>
@@ -6022,7 +5846,7 @@
               </a:defRPr>
             </a:pPr>
             <a:r>
-              <a:t>Transfer orders, human in the loop</a:t>
+              <a:t>The morning briefing: escalate or move</a:t>
             </a:r>
           </a:p>
         </p:txBody>
@@ -6060,7 +5884,7 @@
               </a:defRPr>
             </a:pPr>
             <a:r>
-              <a:t>Solver drafts transfers (OR-Tools)</a:t>
+              <a:t>Short across the district: a supply request to the state, with quantities</a:t>
             </a:r>
           </a:p>
           <a:p>
@@ -6075,7 +5899,7 @@
               </a:defRPr>
             </a:pPr>
             <a:r>
-              <a:t>Officer approves or rejects each</a:t>
+              <a:t>Local imbalance: OR-Tools drafts transfers, most urgent first</a:t>
             </a:r>
           </a:p>
           <a:p>
@@ -6090,21 +5914,36 @@
               </a:defRPr>
             </a:pPr>
             <a:r>
-              <a:t>Orders signed with Cloud KMS; both ends notified</a:t>
+              <a:t>Map before and after the drafted transfers</a:t>
+            </a:r>
+          </a:p>
+          <a:p>
+            <a:pPr>
+              <a:spcAft>
+                <a:spcPts val="1000"/>
+              </a:spcAft>
+              <a:defRPr sz="1800" b="0">
+                <a:solidFill>
+                  <a:srgbClr val="18181B"/>
+                </a:solidFill>
+              </a:defRPr>
+            </a:pPr>
+            <a:r>
+              <a:t>Officer approves; Cloud KMS signs; both facilities alerted on WhatsApp</a:t>
             </a:r>
           </a:p>
         </p:txBody>
       </p:sp>
       <p:pic>
         <p:nvPicPr>
-          <p:cNvPr id="6" name="Picture 5" descr="s92.png"/>
+          <p:cNvPr id="6" name="Picture 5" descr="officer.png"/>
           <p:cNvPicPr>
             <a:picLocks noChangeAspect="1"/>
           </p:cNvPicPr>
           <p:nvPr/>
         </p:nvPicPr>
         <p:blipFill>
-          <a:blip r:embed="rId3"/>
+          <a:blip r:embed="rId4"/>
           <a:stretch>
             <a:fillRect/>
           </a:stretch>
@@ -6289,7 +6128,7 @@
               </a:defRPr>
             </a:pPr>
             <a:r>
-              <a:t>Answers from real forecast and stock data</a:t>
+              <a:t>Answers from live stock and forecast data</a:t>
             </a:r>
           </a:p>
           <a:p>
@@ -6304,7 +6143,7 @@
               </a:defRPr>
             </a:pPr>
             <a:r>
-              <a:t>Jurisdiction-scoped per officer</a:t>
+              <a:t>Gemini adds a plain-language note, dropped if it invents a number</a:t>
             </a:r>
           </a:p>
           <a:p>
@@ -6319,21 +6158,36 @@
               </a:defRPr>
             </a:pPr>
             <a:r>
-              <a:t>Refuses prompt-injection to approve orders</a:t>
+              <a:t>Jurisdiction-scoped per officer</a:t>
+            </a:r>
+          </a:p>
+          <a:p>
+            <a:pPr>
+              <a:spcAft>
+                <a:spcPts val="1000"/>
+              </a:spcAft>
+              <a:defRPr sz="1800" b="0">
+                <a:solidFill>
+                  <a:srgbClr val="18181B"/>
+                </a:solidFill>
+              </a:defRPr>
+            </a:pPr>
+            <a:r>
+              <a:t>No approve or send tool: prompt injection has nothing to call</a:t>
             </a:r>
           </a:p>
         </p:txBody>
       </p:sp>
       <p:pic>
         <p:nvPicPr>
-          <p:cNvPr id="6" name="Picture 5" descr="s112.png"/>
+          <p:cNvPr id="6" name="Picture 5" descr="agent.png"/>
           <p:cNvPicPr>
             <a:picLocks noChangeAspect="1"/>
           </p:cNvPicPr>
           <p:nvPr/>
         </p:nvPicPr>
         <p:blipFill>
-          <a:blip r:embed="rId2"/>
+          <a:blip r:embed="rId3"/>
           <a:stretch>
             <a:fillRect/>
           </a:stretch>
@@ -6442,7 +6296,7 @@
               </a:defRPr>
             </a:pPr>
             <a:r>
-              <a:t>Results</a:t>
+              <a:t>Google AI in the loop</a:t>
             </a:r>
           </a:p>
         </p:txBody>
@@ -6480,7 +6334,7 @@
               </a:defRPr>
             </a:pPr>
             <a:r>
-              <a:t>Measured on a frozen, held-out protocol</a:t>
+              <a:t>Gemini, Chirp and Vertex AI do the reading</a:t>
             </a:r>
           </a:p>
         </p:txBody>
@@ -6493,8 +6347,8 @@
         </p:nvSpPr>
         <p:spPr>
           <a:xfrm>
-            <a:off x="640080" y="1920240"/>
-            <a:ext cx="2651760" cy="914400"/>
+            <a:off x="640080" y="1828800"/>
+            <a:ext cx="3566160" cy="822960"/>
           </a:xfrm>
           <a:prstGeom prst="rect">
             <a:avLst/>
@@ -6511,14 +6365,14 @@
               <a:spcAft>
                 <a:spcPts val="1000"/>
               </a:spcAft>
-              <a:defRPr sz="4800" b="1">
+              <a:defRPr sz="4400" b="1">
                 <a:solidFill>
                   <a:srgbClr val="0F766E"/>
                 </a:solidFill>
               </a:defRPr>
             </a:pPr>
             <a:r>
-              <a:t>0.871</a:t>
+              <a:t>100%</a:t>
             </a:r>
           </a:p>
         </p:txBody>
@@ -6531,8 +6385,8 @@
         </p:nvSpPr>
         <p:spPr>
           <a:xfrm>
-            <a:off x="640080" y="3017520"/>
-            <a:ext cx="2651760" cy="1371600"/>
+            <a:off x="640080" y="2743200"/>
+            <a:ext cx="3566160" cy="731520"/>
           </a:xfrm>
           <a:prstGeom prst="rect">
             <a:avLst/>
@@ -6556,11 +6410,7 @@
               </a:defRPr>
             </a:pPr>
             <a:r>
-              <a:t>Forecast WAPE on real HMIS data</a:t>
-            </a:r>
-            <a:br/>
-            <a:r>
-              <a:t>vs 1.078 naive (19% better)</a:t>
+              <a:t>quantity read correctly</a:t>
             </a:r>
           </a:p>
         </p:txBody>
@@ -6573,8 +6423,8 @@
         </p:nvSpPr>
         <p:spPr>
           <a:xfrm>
-            <a:off x="3474720" y="1920240"/>
-            <a:ext cx="2651760" cy="914400"/>
+            <a:off x="4389120" y="1828800"/>
+            <a:ext cx="3566160" cy="822960"/>
           </a:xfrm>
           <a:prstGeom prst="rect">
             <a:avLst/>
@@ -6591,14 +6441,14 @@
               <a:spcAft>
                 <a:spcPts val="1000"/>
               </a:spcAft>
-              <a:defRPr sz="4800" b="1">
-                <a:solidFill>
-                  <a:srgbClr val="E11D48"/>
-                </a:solidFill>
-              </a:defRPr>
-            </a:pPr>
-            <a:r>
-              <a:t>−6.0%</a:t>
+              <a:defRPr sz="4400" b="1">
+                <a:solidFill>
+                  <a:srgbClr val="0F766E"/>
+                </a:solidFill>
+              </a:defRPr>
+            </a:pPr>
+            <a:r>
+              <a:t>98.1%</a:t>
             </a:r>
           </a:p>
         </p:txBody>
@@ -6611,8 +6461,8 @@
         </p:nvSpPr>
         <p:spPr>
           <a:xfrm>
-            <a:off x="3474720" y="3017520"/>
-            <a:ext cx="2651760" cy="1371600"/>
+            <a:off x="4389120" y="2743200"/>
+            <a:ext cx="3566160" cy="731520"/>
           </a:xfrm>
           <a:prstGeom prst="rect">
             <a:avLst/>
@@ -6636,11 +6486,7 @@
               </a:defRPr>
             </a:pPr>
             <a:r>
-              <a:t>Stock-out weeks in 26-week replay</a:t>
-            </a:r>
-            <a:br/>
-            <a:r>
-              <a:t>(synthetic Nashik ledger)</a:t>
+              <a:t>medicine matched</a:t>
             </a:r>
           </a:p>
         </p:txBody>
@@ -6653,8 +6499,8 @@
         </p:nvSpPr>
         <p:spPr>
           <a:xfrm>
-            <a:off x="6309360" y="1920240"/>
-            <a:ext cx="2651760" cy="914400"/>
+            <a:off x="8138159" y="1828800"/>
+            <a:ext cx="3566160" cy="822960"/>
           </a:xfrm>
           <a:prstGeom prst="rect">
             <a:avLst/>
@@ -6671,14 +6517,14 @@
               <a:spcAft>
                 <a:spcPts val="1000"/>
               </a:spcAft>
-              <a:defRPr sz="4800" b="1">
+              <a:defRPr sz="4400" b="1">
                 <a:solidFill>
                   <a:srgbClr val="0F766E"/>
                 </a:solidFill>
               </a:defRPr>
             </a:pPr>
             <a:r>
-              <a:t>760</a:t>
+              <a:t>4</a:t>
             </a:r>
           </a:p>
         </p:txBody>
@@ -6691,8 +6537,8 @@
         </p:nvSpPr>
         <p:spPr>
           <a:xfrm>
-            <a:off x="6309360" y="3017520"/>
-            <a:ext cx="2651760" cy="1371600"/>
+            <a:off x="8138159" y="2743200"/>
+            <a:ext cx="3566160" cy="731520"/>
           </a:xfrm>
           <a:prstGeom prst="rect">
             <a:avLst/>
@@ -6716,11 +6562,7 @@
               </a:defRPr>
             </a:pPr>
             <a:r>
-              <a:t>Nashik facilities × 16 HMIS</a:t>
-            </a:r>
-            <a:br/>
-            <a:r>
-              <a:t>medicines in the pilot</a:t>
+              <a:t>scripts: English, Devanagari, Tamil, Bengali</a:t>
             </a:r>
           </a:p>
         </p:txBody>
@@ -6733,8 +6575,8 @@
         </p:nvSpPr>
         <p:spPr>
           <a:xfrm>
-            <a:off x="9144000" y="1920240"/>
-            <a:ext cx="2651760" cy="914400"/>
+            <a:off x="640080" y="3840480"/>
+            <a:ext cx="10972800" cy="2286000"/>
           </a:xfrm>
           <a:prstGeom prst="rect">
             <a:avLst/>
@@ -6751,90 +6593,44 @@
               <a:spcAft>
                 <a:spcPts val="1000"/>
               </a:spcAft>
-              <a:defRPr sz="4800" b="1">
-                <a:solidFill>
-                  <a:srgbClr val="0F766E"/>
-                </a:solidFill>
-              </a:defRPr>
-            </a:pPr>
-            <a:r>
-              <a:t>7</a:t>
-            </a:r>
-          </a:p>
-        </p:txBody>
-      </p:sp>
-      <p:sp>
-        <p:nvSpPr>
-          <p:cNvPr id="12" name="TextBox 11"/>
-          <p:cNvSpPr txBox="1"/>
-          <p:nvPr/>
-        </p:nvSpPr>
-        <p:spPr>
-          <a:xfrm>
-            <a:off x="9144000" y="3017520"/>
-            <a:ext cx="2651760" cy="1371600"/>
-          </a:xfrm>
-          <a:prstGeom prst="rect">
-            <a:avLst/>
-          </a:prstGeom>
-          <a:noFill/>
-        </p:spPr>
-        <p:txBody>
-          <a:bodyPr wrap="square">
-            <a:spAutoFit/>
-          </a:bodyPr>
-          <a:lstStyle/>
+              <a:defRPr sz="1600" b="0">
+                <a:solidFill>
+                  <a:srgbClr val="18181B"/>
+                </a:solidFill>
+              </a:defRPr>
+            </a:pPr>
+            <a:r>
+              <a:t>Gemini reads register photos: measured on 206 rendered register lines (synthetic text, not real handwriting).</a:t>
+            </a:r>
+          </a:p>
           <a:p>
             <a:pPr>
               <a:spcAft>
                 <a:spcPts val="1000"/>
               </a:spcAft>
-              <a:defRPr sz="1500" b="0">
-                <a:solidFill>
-                  <a:srgbClr val="52525B"/>
-                </a:solidFill>
-              </a:defRPr>
-            </a:pPr>
-            <a:r>
-              <a:t>Languages end to end</a:t>
-            </a:r>
-          </a:p>
-        </p:txBody>
-      </p:sp>
-      <p:sp>
-        <p:nvSpPr>
-          <p:cNvPr id="13" name="TextBox 12"/>
-          <p:cNvSpPr txBox="1"/>
-          <p:nvPr/>
-        </p:nvSpPr>
-        <p:spPr>
-          <a:xfrm>
-            <a:off x="640080" y="4937760"/>
-            <a:ext cx="10972800" cy="548640"/>
-          </a:xfrm>
-          <a:prstGeom prst="rect">
-            <a:avLst/>
-          </a:prstGeom>
-          <a:noFill/>
-        </p:spPr>
-        <p:txBody>
-          <a:bodyPr wrap="square">
-            <a:spAutoFit/>
-          </a:bodyPr>
-          <a:lstStyle/>
+              <a:defRPr sz="1600" b="0">
+                <a:solidFill>
+                  <a:srgbClr val="18181B"/>
+                </a:solidFill>
+              </a:defRPr>
+            </a:pPr>
+            <a:r>
+              <a:t>Chirp 2 transcribes voice notes and detects the language; Vertex AI embeddings match medicine names in 7 scripts.</a:t>
+            </a:r>
+          </a:p>
           <a:p>
             <a:pPr>
               <a:spcAft>
                 <a:spcPts val="1000"/>
               </a:spcAft>
-              <a:defRPr sz="1500" b="0">
-                <a:solidFill>
-                  <a:srgbClr val="52525B"/>
-                </a:solidFill>
-              </a:defRPr>
-            </a:pPr>
-            <a:r>
-              <a:t>Test window frozen before tuning; first model (L2) lost to naive and stays in the run log.</a:t>
+              <a:defRPr sz="1600" b="0">
+                <a:solidFill>
+                  <a:srgbClr val="18181B"/>
+                </a:solidFill>
+              </a:defRPr>
+            </a:pPr>
+            <a:r>
+              <a:t>Every photo and voice read is confirmed by the nurse before it is saved: a model can be confidently wrong.</a:t>
             </a:r>
           </a:p>
         </p:txBody>
@@ -6930,7 +6726,7 @@
               </a:defRPr>
             </a:pPr>
             <a:r>
-              <a:t>Impact</a:t>
+              <a:t>Results and impact</a:t>
             </a:r>
           </a:p>
         </p:txBody>
@@ -6965,7 +6761,7 @@
               </a:defRPr>
             </a:pPr>
             <a:r>
-              <a:t>AushadhiNet by the numbers</a:t>
+              <a:t>Frozen held-out protocol, and the live demo</a:t>
             </a:r>
           </a:p>
         </p:txBody>
@@ -7035,7 +6831,7 @@
               </a:defRPr>
             </a:pPr>
             <a:r>
-              <a:t>facilities monitored in Nashik pilot</a:t>
+              <a:t>facilities x 16 HMIS medicines in the Nashik pilot</a:t>
             </a:r>
           </a:p>
         </p:txBody>
@@ -7070,7 +6866,7 @@
               </a:defRPr>
             </a:pPr>
             <a:r>
-              <a:t>16</a:t>
+              <a:t>19%</a:t>
             </a:r>
           </a:p>
         </p:txBody>
@@ -7105,7 +6901,7 @@
               </a:defRPr>
             </a:pPr>
             <a:r>
-              <a:t>essential HMIS medicines tracked</a:t>
+              <a:t>lower forecast error than naive on real HMIS data (WAPE 0.871 vs 1.078)</a:t>
             </a:r>
           </a:p>
         </p:txBody>
@@ -7140,7 +6936,7 @@
               </a:defRPr>
             </a:pPr>
             <a:r>
-              <a:t>729</a:t>
+              <a:t>−6%</a:t>
             </a:r>
           </a:p>
         </p:txBody>
@@ -7175,7 +6971,7 @@
               </a:defRPr>
             </a:pPr>
             <a:r>
-              <a:t>facilities flagged at risk before stock-out</a:t>
+              <a:t>stock-out weeks in a 26-week replay (rebalancing, no new supply)</a:t>
             </a:r>
           </a:p>
         </p:txBody>
@@ -7210,7 +7006,7 @@
               </a:defRPr>
             </a:pPr>
             <a:r>
-              <a:t>159</a:t>
+              <a:t>4</a:t>
             </a:r>
           </a:p>
         </p:txBody>
@@ -7245,7 +7041,7 @@
               </a:defRPr>
             </a:pPr>
             <a:r>
-              <a:t>transfer orders drafted by OR-Tools</a:t>
+              <a:t>medicines escalated to the state, with supply quantities</a:t>
             </a:r>
           </a:p>
         </p:txBody>
@@ -7280,7 +7076,7 @@
               </a:defRPr>
             </a:pPr>
             <a:r>
-              <a:t>7,251</a:t>
+              <a:t>7 of 7</a:t>
             </a:r>
           </a:p>
         </p:txBody>
@@ -7315,7 +7111,7 @@
               </a:defRPr>
             </a:pPr>
             <a:r>
-              <a:t>units rebalanced across 186 facilities</a:t>
+              <a:t>transfer-fixable shortages covered by OR-Tools drafts (live)</a:t>
             </a:r>
           </a:p>
         </p:txBody>
@@ -7350,7 +7146,7 @@
               </a:defRPr>
             </a:pPr>
             <a:r>
-              <a:t>19%</a:t>
+              <a:t>98.1%</a:t>
             </a:r>
           </a:p>
         </p:txBody>
@@ -7385,7 +7181,7 @@
               </a:defRPr>
             </a:pPr>
             <a:r>
-              <a:t>lower forecast error than naive (WAPE 0.871)</a:t>
+              <a:t>medicine read correctly by Gemini on register lines (100% quantity)</a:t>
             </a:r>
           </a:p>
         </p:txBody>
@@ -7420,7 +7216,7 @@
               </a:defRPr>
             </a:pPr>
             <a:r>
-              <a:t>−6%</a:t>
+              <a:t>1,90,609</a:t>
             </a:r>
           </a:p>
         </p:txBody>
@@ -7455,7 +7251,7 @@
               </a:defRPr>
             </a:pPr>
             <a:r>
-              <a:t>stock-out weeks in 26-week replay</a:t>
+              <a:t>facilities in 36 states and UTs ready to onboard</a:t>
             </a:r>
           </a:p>
         </p:txBody>
@@ -7525,7 +7321,7 @@
               </a:defRPr>
             </a:pPr>
             <a:r>
-              <a:t>Indian languages, end to end</a:t>
+              <a:t>Indian languages: UI, WhatsApp replies, voice, agent</a:t>
             </a:r>
           </a:p>
         </p:txBody>
@@ -7560,7 +7356,7 @@
               </a:defRPr>
             </a:pPr>
             <a:r>
-              <a:t>349</a:t>
+              <a:t>356</a:t>
             </a:r>
           </a:p>
         </p:txBody>
@@ -7595,7 +7391,7 @@
               </a:defRPr>
             </a:pPr>
             <a:r>
-              <a:t>automated tests (335 backend + 14 E2E, passing on Cloud Run)</a:t>
+              <a:t>automated tests (340 backend + 16 E2E on Cloud Run)</a:t>
             </a:r>
           </a:p>
         </p:txBody>

</xml_diff>

<commit_message>
docs: README mapped to the Track 3 brief with screenshots; beds and staff in deck, demo script, Q&A, API reference; 373 tests
Co-Authored-By: Claude Opus 5.5 <noreply@anthropic.com>
</commit_message>
<xml_diff>
--- a/docs/pitch/AushadhiNet-pitch.pptx
+++ b/docs/pitch/AushadhiNet-pitch.pptx
@@ -5087,7 +5087,7 @@
               </a:defRPr>
             </a:pPr>
             <a:r>
-              <a:t>Nurse sends stock on WhatsApp by text, voice note or register photo, in 7 languages; every machine read is confirmed.</a:t>
+              <a:t>Nurse sends stock on WhatsApp by text, voice note or register photo; beds as 'BEDS 4/6'; checks in by sharing location. 7 languages.</a:t>
             </a:r>
           </a:p>
         </p:txBody>
@@ -5329,7 +5329,7 @@
               </a:defRPr>
             </a:pPr>
             <a:r>
-              <a:t>OR-Tools drafts transfers from nearby surplus. Medicines short district-wide go to the state as a supply request.</a:t>
+              <a:t>OR-Tools drafts transfers from nearby surplus; district-wide gaps go to the state. Full facilities get referrals, staff gaps deputations.</a:t>
             </a:r>
           </a:p>
         </p:txBody>
@@ -5655,7 +5655,7 @@
               </a:defRPr>
             </a:pPr>
             <a:r>
-              <a:t>Several items in one message: “ORS 50 Zinc 120”</a:t>
+              <a:t>Beds as 'BEDS 4/6'; staff check in by sharing location, flagged beyond 200 m</a:t>
             </a:r>
           </a:p>
           <a:p>
@@ -5670,7 +5670,7 @@
               </a:defRPr>
             </a:pPr>
             <a:r>
-              <a:t>Nothing is saved until the nurse replies YES</a:t>
+              <a:t>Nothing read by a model is saved until the nurse replies YES</a:t>
             </a:r>
           </a:p>
           <a:p>
@@ -5692,22 +5692,22 @@
       </p:sp>
       <p:pic>
         <p:nvPicPr>
-          <p:cNvPr id="6" name="Picture 5" descr="nurse.png"/>
+          <p:cNvPr id="6" name="Picture 5" descr="whatsapp.png"/>
           <p:cNvPicPr>
             <a:picLocks noChangeAspect="1"/>
           </p:cNvPicPr>
           <p:nvPr/>
         </p:nvPicPr>
         <p:blipFill>
-          <a:blip r:embed="rId4"/>
+          <a:blip r:embed="rId5"/>
           <a:stretch>
             <a:fillRect/>
           </a:stretch>
         </p:blipFill>
         <p:spPr>
           <a:xfrm>
-            <a:off x="4937760" y="1645920"/>
-            <a:ext cx="6949440" cy="3909060"/>
+            <a:off x="4937760" y="1428750"/>
+            <a:ext cx="6949440" cy="4343400"/>
           </a:xfrm>
           <a:prstGeom prst="rect">
             <a:avLst/>
@@ -5914,7 +5914,7 @@
               </a:defRPr>
             </a:pPr>
             <a:r>
-              <a:t>Map before and after the drafted transfers</a:t>
+              <a:t>Beds and staff today: referral and deputation suggestions</a:t>
             </a:r>
           </a:p>
           <a:p>
@@ -7356,7 +7356,7 @@
               </a:defRPr>
             </a:pPr>
             <a:r>
-              <a:t>360</a:t>
+              <a:t>373</a:t>
             </a:r>
           </a:p>
         </p:txBody>
@@ -7391,7 +7391,7 @@
               </a:defRPr>
             </a:pPr>
             <a:r>
-              <a:t>automated tests (344 backend + 16 E2E on Cloud Run)</a:t>
+              <a:t>automated tests (356 backend + 17 E2E on Cloud Run)</a:t>
             </a:r>
           </a:p>
         </p:txBody>

</xml_diff>

<commit_message>
docs: live/offline/planned labels throughout; replay trade-off, federation as a simulation, judge Q&A; deck updated; federated re-run appended
Co-Authored-By: Claude Opus 5.5 <noreply@anthropic.com>
</commit_message>
<xml_diff>
--- a/docs/pitch/AushadhiNet-pitch.pptx
+++ b/docs/pitch/AushadhiNet-pitch.pptx
@@ -3465,7 +3465,7 @@
               </a:defRPr>
             </a:pPr>
             <a:r>
-              <a:t>Every state is already in the system</a:t>
+              <a:t>Every state is listed; one district is live</a:t>
             </a:r>
           </a:p>
         </p:txBody>
@@ -3503,7 +3503,7 @@
               </a:defRPr>
             </a:pPr>
             <a:r>
-              <a:t>1,90,609 facilities in 678 districts, 36 states and UTs (MoHFW directory)</a:t>
+              <a:t>1,90,609 facilities in 678 districts, 36 states and UTs (MoHFW directory), unique IDs</a:t>
             </a:r>
           </a:p>
           <a:p>
@@ -3533,7 +3533,7 @@
               </a:defRPr>
             </a:pPr>
             <a:r>
-              <a:t>One Google Cloud project per state; data stays in-state</a:t>
+              <a:t>Federated training, simulated on 4 states' HMIS data: shares model updates, not rows; ties local-only</a:t>
             </a:r>
           </a:p>
           <a:p>
@@ -3548,7 +3548,7 @@
               </a:defRPr>
             </a:pPr>
             <a:r>
-              <a:t>Languages are data: a new one is a translation file</a:t>
+              <a:t>Planned: one Google Cloud project per state, running that federation for real</a:t>
             </a:r>
           </a:p>
           <a:p>
@@ -3563,7 +3563,7 @@
               </a:defRPr>
             </a:pPr>
             <a:r>
-              <a:t>BRICS: swap the facility list, the WHO medicines list and the language</a:t>
+              <a:t>Languages are data: a new one is a translation file</a:t>
             </a:r>
           </a:p>
         </p:txBody>
@@ -3800,7 +3800,7 @@
               </a:defRPr>
             </a:pPr>
             <a:r>
-              <a:t>terraform apply creates the state's project (37 resources) and Cloud Build deploys: this one took a day. Load one block's nurse numbers; connect Twilio and Firebase sign-in.</a:t>
+              <a:t>terraform apply provisions the state's 37 resources in its Google Cloud project; Cloud Build deploys: this one took a day. Load one block's nurse numbers; set up Twilio and Firebase sign-in.</a:t>
             </a:r>
           </a:p>
         </p:txBody>
@@ -3952,7 +3952,7 @@
               </a:defRPr>
             </a:pPr>
             <a:r>
-              <a:t>The officer approves transfers and sends supply requests. Compare stock-out weeks with the same weeks last year.</a:t>
+              <a:t>The officer approves transfers and sends supply requests. Compare stock-out weeks with a matched block not yet using it, same weeks.</a:t>
             </a:r>
           </a:p>
         </p:txBody>
@@ -5208,7 +5208,7 @@
               </a:defRPr>
             </a:pPr>
             <a:r>
-              <a:t>Next-week demand and stock-out probability per facility and medicine; model chosen by measurement on real HMIS data.</a:t>
+              <a:t>Next-week demand per facility from the last ledger week (beat LightGBM at this grain); stock-out risk from live stock.</a:t>
             </a:r>
           </a:p>
         </p:txBody>
@@ -5329,7 +5329,7 @@
               </a:defRPr>
             </a:pPr>
             <a:r>
-              <a:t>OR-Tools drafts transfers from nearby surplus; district-wide gaps go to the state. Full facilities get referrals, staff gaps deputations.</a:t>
+              <a:t>OR-Tools drafts transfers within a district or state-wide across districts (min 10 units). District-wide gaps also go to the state. Beds: referrals; staff: deputations.</a:t>
             </a:r>
           </a:p>
         </p:txBody>
@@ -5450,7 +5450,7 @@
               </a:defRPr>
             </a:pPr>
             <a:r>
-              <a:t>Officer approves; signed order to both facilities. The AI agent explains and drafts, never approves.</a:t>
+              <a:t>Approved only if the donor still has the units; KMS-signed to both ends; receiver confirms arrival. The agent never approves.</a:t>
             </a:r>
           </a:p>
         </p:txBody>
@@ -6761,7 +6761,7 @@
               </a:defRPr>
             </a:pPr>
             <a:r>
-              <a:t>Frozen held-out protocol, and the live demo</a:t>
+              <a:t>Live = deployed simulated pilot; offline = frozen evaluation</a:t>
             </a:r>
           </a:p>
         </p:txBody>
@@ -6901,7 +6901,7 @@
               </a:defRPr>
             </a:pPr>
             <a:r>
-              <a:t>lower forecast error than naive on real HMIS data (WAPE 0.871 vs 1.078)</a:t>
+              <a:t>lower error than naive on real HMIS district-month data (offline; the app serves naive)</a:t>
             </a:r>
           </a:p>
         </p:txBody>
@@ -6971,7 +6971,7 @@
               </a:defRPr>
             </a:pPr>
             <a:r>
-              <a:t>stock-out weeks in a 26-week replay (rebalancing, no new supply)</a:t>
+              <a:t>stock-out weeks in a 26-week replay, but unmet units +0.25% and ~570 transfers a week (offline)</a:t>
             </a:r>
           </a:p>
         </p:txBody>
@@ -7076,7 +7076,7 @@
               </a:defRPr>
             </a:pPr>
             <a:r>
-              <a:t>7 of 7</a:t>
+              <a:t>77</a:t>
             </a:r>
           </a:p>
         </p:txBody>
@@ -7111,7 +7111,7 @@
               </a:defRPr>
             </a:pPr>
             <a:r>
-              <a:t>transfer-fixable shortages covered by OR-Tools drafts (live)</a:t>
+              <a:t>transfer drafts for Nashik: ≥10 units, ≤5 donors per need (live)</a:t>
             </a:r>
           </a:p>
         </p:txBody>
@@ -7251,7 +7251,7 @@
               </a:defRPr>
             </a:pPr>
             <a:r>
-              <a:t>facilities in 36 states and UTs ready to onboard</a:t>
+              <a:t>facilities in 36 states and UTs listed, ready to onboard (not yet reporting)</a:t>
             </a:r>
           </a:p>
         </p:txBody>
@@ -7356,7 +7356,7 @@
               </a:defRPr>
             </a:pPr>
             <a:r>
-              <a:t>373</a:t>
+              <a:t>392</a:t>
             </a:r>
           </a:p>
         </p:txBody>
@@ -7391,7 +7391,7 @@
               </a:defRPr>
             </a:pPr>
             <a:r>
-              <a:t>automated tests (356 backend + 17 E2E on Cloud Run)</a:t>
+              <a:t>automated tests (375 backend + 17 E2E on Cloud Run)</a:t>
             </a:r>
           </a:p>
         </p:txBody>

</xml_diff>